<commit_message>
Apply Morph transitions across the presentation
Co-Authored-By: Claude Opus 5.5 <noreply@anthropic.com>
Claude-Session: https://claude.ai/code/session_01YYaU7gjrydFfrBZ3c2XcNV
</commit_message>
<xml_diff>
--- a/presentations/مركز_البيانات_الوطني_الجيل_الجديد.pptx
+++ b/presentations/مركز_البيانات_الوطني_الجيل_الجديد.pptx
@@ -129,17 +129,17 @@
   <p:extLst>
     <p:ext uri="{521415D9-36F7-43E2-AB2F-B90AF26B5E84}">
       <p14:sectionLst xmlns:p14="http://schemas.microsoft.com/office/powerpoint/2010/main">
-        <p14:section name="الغلاف" id="{4c560b3e-8e73-ed21-a0a3-ea91f1eb2a63}">
+        <p14:section name="الغلاف" id="{aeed6063-c77e-5848-300e-d1a89fc5e16e}">
           <p14:sldIdLst>
             <p14:sldId id="256"/>
           </p14:sldIdLst>
         </p14:section>
-        <p14:section name="المحتويات" id="{89f3ee84-7404-f63f-8409-032fa7f8b077}">
+        <p14:section name="المحتويات" id="{0ca4c477-03d5-6bcc-817c-ae184ce2f7d2}">
           <p14:sldIdLst>
             <p14:sldId id="257"/>
           </p14:sldIdLst>
         </p14:section>
-        <p14:section name="01 التعريف بالمشروع" id="{b31f2b61-4d11-ada1-f7e3-1355784699aa}">
+        <p14:section name="01 التعريف بالمشروع" id="{9312fbbb-71e4-b609-990f-258c78b29daf}">
           <p14:sldIdLst>
             <p14:sldId id="258"/>
             <p14:sldId id="259"/>
@@ -147,59 +147,59 @@
             <p14:sldId id="261"/>
           </p14:sldIdLst>
         </p14:section>
-        <p14:section name="02 نقاط القوة" id="{361d63f1-be74-a548-a616-1e30368fc219}">
+        <p14:section name="02 نقاط القوة" id="{80a2ded3-da51-afbe-40a7-917176966899}">
           <p14:sldIdLst>
             <p14:sldId id="262"/>
             <p14:sldId id="263"/>
           </p14:sldIdLst>
         </p14:section>
-        <p14:section name="03 تحليل SWOT" id="{be13ffbf-0551-c752-71e2-4dc312826be8}">
+        <p14:section name="03 تحليل SWOT" id="{72ee013f-50f0-401a-dd70-1fb4ec4afd73}">
           <p14:sldIdLst>
             <p14:sldId id="264"/>
           </p14:sldIdLst>
         </p14:section>
-        <p14:section name="04 التكاليف الرأسمالية" id="{e3f1c6e1-0305-6622-73db-9c2f24aa93d9}">
+        <p14:section name="04 التكاليف الرأسمالية" id="{0f3c97d1-1d27-af84-8697-a7582da8fec3}">
           <p14:sldIdLst>
             <p14:sldId id="265"/>
             <p14:sldId id="266"/>
           </p14:sldIdLst>
         </p14:section>
-        <p14:section name="05 التكاليف التشغيلية" id="{66f3ac8b-1496-4763-5a81-ddc7233d1d21}">
+        <p14:section name="05 التكاليف التشغيلية" id="{8fc85cbe-4433-53d3-cb32-5e6c935d4511}">
           <p14:sldIdLst>
             <p14:sldId id="267"/>
             <p14:sldId id="268"/>
           </p14:sldIdLst>
         </p14:section>
-        <p14:section name="06 الإيرادات المتوقعة" id="{95dbd3a2-3de0-61d6-b346-7da604884f68}">
+        <p14:section name="06 الإيرادات المتوقعة" id="{d0f30264-be4f-847a-5867-19bc40a3b0d2}">
           <p14:sldIdLst>
             <p14:sldId id="269"/>
             <p14:sldId id="270"/>
           </p14:sldIdLst>
         </p14:section>
-        <p14:section name="07 المؤشرات المالية" id="{4d488450-0fe7-e912-b7ac-48c891412021}">
+        <p14:section name="07 المؤشرات المالية" id="{5bdfd066-d99f-36f3-87e9-165ed2944386}">
           <p14:sldIdLst>
             <p14:sldId id="271"/>
             <p14:sldId id="272"/>
           </p14:sldIdLst>
         </p14:section>
-        <p14:section name="08 نماذج التمويل" id="{9382920d-344e-2f7d-c002-ffa249c6afd2}">
+        <p14:section name="08 نماذج التمويل" id="{d9b6b09f-d4a8-89a6-c056-617ca97d8bd0}">
           <p14:sldIdLst>
             <p14:sldId id="273"/>
           </p14:sldIdLst>
         </p14:section>
-        <p14:section name="09 النتائج الرئيسية" id="{1db5d660-775a-f58b-4a69-47754e345442}">
+        <p14:section name="09 النتائج الرئيسية" id="{ac5abcfd-80ae-5a16-0be3-8f21784694bd}">
           <p14:sldIdLst>
             <p14:sldId id="274"/>
             <p14:sldId id="275"/>
           </p14:sldIdLst>
         </p14:section>
-        <p14:section name="10 التوصيات والفوائد" id="{3675764d-28c8-4845-ea57-3e94c69ef171}">
+        <p14:section name="10 التوصيات والفوائد" id="{9c5760ac-8096-ec30-13ba-ca911df9ada9}">
           <p14:sldIdLst>
             <p14:sldId id="276"/>
             <p14:sldId id="277"/>
           </p14:sldIdLst>
         </p14:section>
-        <p14:section name="الختام" id="{15da2e56-5e63-8937-8aa7-aec55e941c5c}">
+        <p14:section name="الختام" id="{e07a95c5-c635-79c6-f5b9-61b261b071f1}">
           <p14:sldIdLst>
             <p14:sldId id="278"/>
           </p14:sldIdLst>
@@ -4079,7 +4079,7 @@
       </p:grpSpPr>
       <p:pic>
         <p:nvPicPr>
-          <p:cNvPr id="2" name="Image 0" descr="assets/logo_white.png">    </p:cNvPr>
+          <p:cNvPr id="2" name="!!heroLogo" descr="assets/logo_white.png">    </p:cNvPr>
           <p:cNvPicPr>
             <a:picLocks noChangeAspect="1"/>
           </p:cNvPicPr>
@@ -4671,6 +4671,18 @@
   <p:clrMapOvr>
     <a:masterClrMapping/>
   </p:clrMapOvr>
+  <mc:AlternateContent xmlns:mc="http://schemas.openxmlformats.org/markup-compatibility/2006">
+    <mc:Choice xmlns:p159="http://schemas.microsoft.com/office/powerpoint/2015/09/main" Requires="p159">
+      <p:transition xmlns:p14="http://schemas.microsoft.com/office/powerpoint/2010/main" spd="slow" p14:dur="1250">
+        <p159:morph option="byObject"/>
+      </p:transition>
+    </mc:Choice>
+    <mc:Fallback>
+      <p:transition spd="slow">
+        <p:fade/>
+      </p:transition>
+    </mc:Fallback>
+  </mc:AlternateContent>
 </p:sld>
 </file>
 
@@ -5663,7 +5675,7 @@
       </p:graphicFrame>
       <p:sp>
         <p:nvSpPr>
-          <p:cNvPr id="6" name="Shape 3"/>
+          <p:cNvPr id="6" name="!!card0"/>
           <p:cNvSpPr/>
           <p:nvPr/>
         </p:nvSpPr>
@@ -5690,7 +5702,7 @@
       </p:sp>
       <p:sp>
         <p:nvSpPr>
-          <p:cNvPr id="7" name="Shape 4"/>
+          <p:cNvPr id="7" name="!!dot0"/>
           <p:cNvSpPr/>
           <p:nvPr/>
         </p:nvSpPr>
@@ -5715,7 +5727,7 @@
       </p:sp>
       <p:pic>
         <p:nvPicPr>
-          <p:cNvPr id="8" name="Image 0" descr="preencoded.png">    </p:cNvPr>
+          <p:cNvPr id="8" name="!!ico0" descr="preencoded.png">    </p:cNvPr>
           <p:cNvPicPr>
             <a:picLocks noChangeAspect="1"/>
           </p:cNvPicPr>
@@ -5817,7 +5829,7 @@
       </p:sp>
       <p:sp>
         <p:nvSpPr>
-          <p:cNvPr id="11" name="Shape 7"/>
+          <p:cNvPr id="11" name="!!card1"/>
           <p:cNvSpPr/>
           <p:nvPr/>
         </p:nvSpPr>
@@ -5844,7 +5856,7 @@
       </p:sp>
       <p:sp>
         <p:nvSpPr>
-          <p:cNvPr id="12" name="Shape 8"/>
+          <p:cNvPr id="12" name="!!dot1"/>
           <p:cNvSpPr/>
           <p:nvPr/>
         </p:nvSpPr>
@@ -5869,7 +5881,7 @@
       </p:sp>
       <p:pic>
         <p:nvPicPr>
-          <p:cNvPr id="13" name="Image 1" descr="preencoded.png">    </p:cNvPr>
+          <p:cNvPr id="13" name="!!ico1" descr="preencoded.png">    </p:cNvPr>
           <p:cNvPicPr>
             <a:picLocks noChangeAspect="1"/>
           </p:cNvPicPr>
@@ -5971,7 +5983,7 @@
       </p:sp>
       <p:sp>
         <p:nvSpPr>
-          <p:cNvPr id="16" name="Shape 11"/>
+          <p:cNvPr id="16" name="!!card2"/>
           <p:cNvSpPr/>
           <p:nvPr/>
         </p:nvSpPr>
@@ -6395,6 +6407,18 @@
   <p:clrMapOvr>
     <a:masterClrMapping/>
   </p:clrMapOvr>
+  <mc:AlternateContent xmlns:mc="http://schemas.openxmlformats.org/markup-compatibility/2006">
+    <mc:Choice xmlns:p159="http://schemas.microsoft.com/office/powerpoint/2015/09/main" Requires="p159">
+      <p:transition xmlns:p14="http://schemas.microsoft.com/office/powerpoint/2010/main" spd="slow" p14:dur="1250">
+        <p159:morph option="byObject"/>
+      </p:transition>
+    </mc:Choice>
+    <mc:Fallback>
+      <p:transition spd="slow">
+        <p:fade/>
+      </p:transition>
+    </mc:Fallback>
+  </mc:AlternateContent>
 </p:sld>
 </file>
 
@@ -6499,7 +6523,7 @@
       </p:sp>
       <p:sp>
         <p:nvSpPr>
-          <p:cNvPr id="4" name="Shape 2"/>
+          <p:cNvPr id="4" name="!!card0"/>
           <p:cNvSpPr/>
           <p:nvPr/>
         </p:nvSpPr>
@@ -6533,7 +6557,7 @@
       </p:sp>
       <p:sp>
         <p:nvSpPr>
-          <p:cNvPr id="5" name="Shape 3"/>
+          <p:cNvPr id="5" name="!!dot0"/>
           <p:cNvSpPr/>
           <p:nvPr/>
         </p:nvSpPr>
@@ -6558,7 +6582,7 @@
       </p:sp>
       <p:pic>
         <p:nvPicPr>
-          <p:cNvPr id="6" name="Image 0" descr="preencoded.png">    </p:cNvPr>
+          <p:cNvPr id="6" name="!!ico0" descr="preencoded.png">    </p:cNvPr>
           <p:cNvPicPr>
             <a:picLocks noChangeAspect="1"/>
           </p:cNvPicPr>
@@ -6660,7 +6684,7 @@
       </p:sp>
       <p:sp>
         <p:nvSpPr>
-          <p:cNvPr id="9" name="Shape 6"/>
+          <p:cNvPr id="9" name="!!card1"/>
           <p:cNvSpPr/>
           <p:nvPr/>
         </p:nvSpPr>
@@ -6694,7 +6718,7 @@
       </p:sp>
       <p:sp>
         <p:nvSpPr>
-          <p:cNvPr id="10" name="Shape 7"/>
+          <p:cNvPr id="10" name="!!dot1"/>
           <p:cNvSpPr/>
           <p:nvPr/>
         </p:nvSpPr>
@@ -6719,7 +6743,7 @@
       </p:sp>
       <p:pic>
         <p:nvPicPr>
-          <p:cNvPr id="11" name="Image 1" descr="preencoded.png">    </p:cNvPr>
+          <p:cNvPr id="11" name="!!ico1" descr="preencoded.png">    </p:cNvPr>
           <p:cNvPicPr>
             <a:picLocks noChangeAspect="1"/>
           </p:cNvPicPr>
@@ -6821,7 +6845,7 @@
       </p:sp>
       <p:sp>
         <p:nvSpPr>
-          <p:cNvPr id="14" name="Shape 10"/>
+          <p:cNvPr id="14" name="!!card2"/>
           <p:cNvSpPr/>
           <p:nvPr/>
         </p:nvSpPr>
@@ -6855,7 +6879,7 @@
       </p:sp>
       <p:sp>
         <p:nvSpPr>
-          <p:cNvPr id="15" name="Shape 11"/>
+          <p:cNvPr id="15" name="!!dot2"/>
           <p:cNvSpPr/>
           <p:nvPr/>
         </p:nvSpPr>
@@ -6880,7 +6904,7 @@
       </p:sp>
       <p:pic>
         <p:nvPicPr>
-          <p:cNvPr id="16" name="Image 2" descr="preencoded.png">    </p:cNvPr>
+          <p:cNvPr id="16" name="!!ico2" descr="preencoded.png">    </p:cNvPr>
           <p:cNvPicPr>
             <a:picLocks noChangeAspect="1"/>
           </p:cNvPicPr>
@@ -6982,7 +7006,7 @@
       </p:sp>
       <p:sp>
         <p:nvSpPr>
-          <p:cNvPr id="19" name="Shape 14"/>
+          <p:cNvPr id="19" name="!!card3"/>
           <p:cNvSpPr/>
           <p:nvPr/>
         </p:nvSpPr>
@@ -7016,7 +7040,7 @@
       </p:sp>
       <p:sp>
         <p:nvSpPr>
-          <p:cNvPr id="20" name="Shape 15"/>
+          <p:cNvPr id="20" name="!!dot3"/>
           <p:cNvSpPr/>
           <p:nvPr/>
         </p:nvSpPr>
@@ -7041,7 +7065,7 @@
       </p:sp>
       <p:pic>
         <p:nvPicPr>
-          <p:cNvPr id="21" name="Image 3" descr="preencoded.png">    </p:cNvPr>
+          <p:cNvPr id="21" name="!!ico3" descr="preencoded.png">    </p:cNvPr>
           <p:cNvPicPr>
             <a:picLocks noChangeAspect="1"/>
           </p:cNvPicPr>
@@ -7143,7 +7167,7 @@
       </p:sp>
       <p:sp>
         <p:nvSpPr>
-          <p:cNvPr id="24" name="Shape 18"/>
+          <p:cNvPr id="24" name="!!card4"/>
           <p:cNvSpPr/>
           <p:nvPr/>
         </p:nvSpPr>
@@ -7177,7 +7201,7 @@
       </p:sp>
       <p:sp>
         <p:nvSpPr>
-          <p:cNvPr id="25" name="Shape 19"/>
+          <p:cNvPr id="25" name="!!dot4"/>
           <p:cNvSpPr/>
           <p:nvPr/>
         </p:nvSpPr>
@@ -7202,7 +7226,7 @@
       </p:sp>
       <p:pic>
         <p:nvPicPr>
-          <p:cNvPr id="26" name="Image 4" descr="preencoded.png">    </p:cNvPr>
+          <p:cNvPr id="26" name="!!ico4" descr="preencoded.png">    </p:cNvPr>
           <p:cNvPicPr>
             <a:picLocks noChangeAspect="1"/>
           </p:cNvPicPr>
@@ -7304,7 +7328,7 @@
       </p:sp>
       <p:sp>
         <p:nvSpPr>
-          <p:cNvPr id="29" name="Shape 22"/>
+          <p:cNvPr id="29" name="!!card5"/>
           <p:cNvSpPr/>
           <p:nvPr/>
         </p:nvSpPr>
@@ -7338,7 +7362,7 @@
       </p:sp>
       <p:sp>
         <p:nvSpPr>
-          <p:cNvPr id="30" name="Shape 23"/>
+          <p:cNvPr id="30" name="!!dot5"/>
           <p:cNvSpPr/>
           <p:nvPr/>
         </p:nvSpPr>
@@ -7363,7 +7387,7 @@
       </p:sp>
       <p:pic>
         <p:nvPicPr>
-          <p:cNvPr id="31" name="Image 5" descr="preencoded.png">    </p:cNvPr>
+          <p:cNvPr id="31" name="!!ico5" descr="preencoded.png">    </p:cNvPr>
           <p:cNvPicPr>
             <a:picLocks noChangeAspect="1"/>
           </p:cNvPicPr>
@@ -7465,7 +7489,7 @@
       </p:sp>
       <p:sp>
         <p:nvSpPr>
-          <p:cNvPr id="34" name="Shape 26"/>
+          <p:cNvPr id="34" name="!!card6"/>
           <p:cNvSpPr/>
           <p:nvPr/>
         </p:nvSpPr>
@@ -7499,7 +7523,7 @@
       </p:sp>
       <p:sp>
         <p:nvSpPr>
-          <p:cNvPr id="35" name="Shape 27"/>
+          <p:cNvPr id="35" name="!!dot6"/>
           <p:cNvSpPr/>
           <p:nvPr/>
         </p:nvSpPr>
@@ -7524,7 +7548,7 @@
       </p:sp>
       <p:pic>
         <p:nvPicPr>
-          <p:cNvPr id="36" name="Image 6" descr="preencoded.png">    </p:cNvPr>
+          <p:cNvPr id="36" name="!!ico6" descr="preencoded.png">    </p:cNvPr>
           <p:cNvPicPr>
             <a:picLocks noChangeAspect="1"/>
           </p:cNvPicPr>
@@ -7626,7 +7650,7 @@
       </p:sp>
       <p:sp>
         <p:nvSpPr>
-          <p:cNvPr id="39" name="Shape 30"/>
+          <p:cNvPr id="39" name="!!card7"/>
           <p:cNvSpPr/>
           <p:nvPr/>
         </p:nvSpPr>
@@ -7660,7 +7684,7 @@
       </p:sp>
       <p:sp>
         <p:nvSpPr>
-          <p:cNvPr id="40" name="Shape 31"/>
+          <p:cNvPr id="40" name="!!dot7"/>
           <p:cNvSpPr/>
           <p:nvPr/>
         </p:nvSpPr>
@@ -7685,7 +7709,7 @@
       </p:sp>
       <p:pic>
         <p:nvPicPr>
-          <p:cNvPr id="41" name="Image 7" descr="preencoded.png">    </p:cNvPr>
+          <p:cNvPr id="41" name="!!ico7" descr="preencoded.png">    </p:cNvPr>
           <p:cNvPicPr>
             <a:picLocks noChangeAspect="1"/>
           </p:cNvPicPr>
@@ -7787,7 +7811,7 @@
       </p:sp>
       <p:sp>
         <p:nvSpPr>
-          <p:cNvPr id="44" name="Shape 34"/>
+          <p:cNvPr id="44" name="!!card8"/>
           <p:cNvSpPr/>
           <p:nvPr/>
         </p:nvSpPr>
@@ -7821,7 +7845,7 @@
       </p:sp>
       <p:sp>
         <p:nvSpPr>
-          <p:cNvPr id="45" name="Shape 35"/>
+          <p:cNvPr id="45" name="!!dot8"/>
           <p:cNvSpPr/>
           <p:nvPr/>
         </p:nvSpPr>
@@ -7846,7 +7870,7 @@
       </p:sp>
       <p:pic>
         <p:nvPicPr>
-          <p:cNvPr id="46" name="Image 8" descr="preencoded.png">    </p:cNvPr>
+          <p:cNvPr id="46" name="!!ico8" descr="preencoded.png">    </p:cNvPr>
           <p:cNvPicPr>
             <a:picLocks noChangeAspect="1"/>
           </p:cNvPicPr>
@@ -7948,7 +7972,7 @@
       </p:sp>
       <p:sp>
         <p:nvSpPr>
-          <p:cNvPr id="49" name="Shape 38"/>
+          <p:cNvPr id="49" name="!!card9"/>
           <p:cNvSpPr/>
           <p:nvPr/>
         </p:nvSpPr>
@@ -8216,6 +8240,18 @@
   <p:clrMapOvr>
     <a:masterClrMapping/>
   </p:clrMapOvr>
+  <mc:AlternateContent xmlns:mc="http://schemas.openxmlformats.org/markup-compatibility/2006">
+    <mc:Choice xmlns:p159="http://schemas.microsoft.com/office/powerpoint/2015/09/main" Requires="p159">
+      <p:transition xmlns:p14="http://schemas.microsoft.com/office/powerpoint/2010/main" spd="slow" p14:dur="1250">
+        <p159:morph option="byObject"/>
+      </p:transition>
+    </mc:Choice>
+    <mc:Fallback>
+      <p:transition spd="slow">
+        <p:fade/>
+      </p:transition>
+    </mc:Fallback>
+  </mc:AlternateContent>
 </p:sld>
 </file>
 
@@ -8359,7 +8395,7 @@
       </p:sp>
       <p:sp>
         <p:nvSpPr>
-          <p:cNvPr id="5" name="Shape 3"/>
+          <p:cNvPr id="5" name="!!card0"/>
           <p:cNvSpPr/>
           <p:nvPr/>
         </p:nvSpPr>
@@ -8393,7 +8429,7 @@
       </p:sp>
       <p:sp>
         <p:nvSpPr>
-          <p:cNvPr id="6" name="Shape 4"/>
+          <p:cNvPr id="6" name="!!dot0"/>
           <p:cNvSpPr/>
           <p:nvPr/>
         </p:nvSpPr>
@@ -8418,7 +8454,7 @@
       </p:sp>
       <p:pic>
         <p:nvPicPr>
-          <p:cNvPr id="7" name="Image 0" descr="preencoded.png">    </p:cNvPr>
+          <p:cNvPr id="7" name="!!ico0" descr="preencoded.png">    </p:cNvPr>
           <p:cNvPicPr>
             <a:picLocks noChangeAspect="1"/>
           </p:cNvPicPr>
@@ -8520,7 +8556,7 @@
       </p:sp>
       <p:sp>
         <p:nvSpPr>
-          <p:cNvPr id="10" name="Shape 7"/>
+          <p:cNvPr id="10" name="!!card1"/>
           <p:cNvSpPr/>
           <p:nvPr/>
         </p:nvSpPr>
@@ -8554,7 +8590,7 @@
       </p:sp>
       <p:sp>
         <p:nvSpPr>
-          <p:cNvPr id="11" name="Shape 8"/>
+          <p:cNvPr id="11" name="!!dot1"/>
           <p:cNvSpPr/>
           <p:nvPr/>
         </p:nvSpPr>
@@ -8579,7 +8615,7 @@
       </p:sp>
       <p:pic>
         <p:nvPicPr>
-          <p:cNvPr id="12" name="Image 1" descr="preencoded.png">    </p:cNvPr>
+          <p:cNvPr id="12" name="!!ico1" descr="preencoded.png">    </p:cNvPr>
           <p:cNvPicPr>
             <a:picLocks noChangeAspect="1"/>
           </p:cNvPicPr>
@@ -8681,7 +8717,7 @@
       </p:sp>
       <p:sp>
         <p:nvSpPr>
-          <p:cNvPr id="15" name="Shape 11"/>
+          <p:cNvPr id="15" name="!!card2"/>
           <p:cNvSpPr/>
           <p:nvPr/>
         </p:nvSpPr>
@@ -8715,7 +8751,7 @@
       </p:sp>
       <p:sp>
         <p:nvSpPr>
-          <p:cNvPr id="16" name="Shape 12"/>
+          <p:cNvPr id="16" name="!!dot2"/>
           <p:cNvSpPr/>
           <p:nvPr/>
         </p:nvSpPr>
@@ -8740,7 +8776,7 @@
       </p:sp>
       <p:pic>
         <p:nvPicPr>
-          <p:cNvPr id="17" name="Image 2" descr="preencoded.png">    </p:cNvPr>
+          <p:cNvPr id="17" name="!!ico2" descr="preencoded.png">    </p:cNvPr>
           <p:cNvPicPr>
             <a:picLocks noChangeAspect="1"/>
           </p:cNvPicPr>
@@ -8842,7 +8878,7 @@
       </p:sp>
       <p:sp>
         <p:nvSpPr>
-          <p:cNvPr id="20" name="Shape 15"/>
+          <p:cNvPr id="20" name="!!card3"/>
           <p:cNvSpPr/>
           <p:nvPr/>
         </p:nvSpPr>
@@ -8876,7 +8912,7 @@
       </p:sp>
       <p:sp>
         <p:nvSpPr>
-          <p:cNvPr id="21" name="Shape 16"/>
+          <p:cNvPr id="21" name="!!dot3"/>
           <p:cNvSpPr/>
           <p:nvPr/>
         </p:nvSpPr>
@@ -8901,7 +8937,7 @@
       </p:sp>
       <p:pic>
         <p:nvPicPr>
-          <p:cNvPr id="22" name="Image 3" descr="preencoded.png">    </p:cNvPr>
+          <p:cNvPr id="22" name="!!ico3" descr="preencoded.png">    </p:cNvPr>
           <p:cNvPicPr>
             <a:picLocks noChangeAspect="1"/>
           </p:cNvPicPr>
@@ -9003,7 +9039,7 @@
       </p:sp>
       <p:sp>
         <p:nvSpPr>
-          <p:cNvPr id="25" name="Shape 19"/>
+          <p:cNvPr id="25" name="!!card4"/>
           <p:cNvSpPr/>
           <p:nvPr/>
         </p:nvSpPr>
@@ -9037,7 +9073,7 @@
       </p:sp>
       <p:sp>
         <p:nvSpPr>
-          <p:cNvPr id="26" name="Shape 20"/>
+          <p:cNvPr id="26" name="!!dot4"/>
           <p:cNvSpPr/>
           <p:nvPr/>
         </p:nvSpPr>
@@ -9062,7 +9098,7 @@
       </p:sp>
       <p:pic>
         <p:nvPicPr>
-          <p:cNvPr id="27" name="Image 4" descr="preencoded.png">    </p:cNvPr>
+          <p:cNvPr id="27" name="!!ico4" descr="preencoded.png">    </p:cNvPr>
           <p:cNvPicPr>
             <a:picLocks noChangeAspect="1"/>
           </p:cNvPicPr>
@@ -9164,7 +9200,7 @@
       </p:sp>
       <p:sp>
         <p:nvSpPr>
-          <p:cNvPr id="30" name="Shape 23"/>
+          <p:cNvPr id="30" name="!!card5"/>
           <p:cNvSpPr/>
           <p:nvPr/>
         </p:nvSpPr>
@@ -9198,7 +9234,7 @@
       </p:sp>
       <p:sp>
         <p:nvSpPr>
-          <p:cNvPr id="31" name="Shape 24"/>
+          <p:cNvPr id="31" name="!!dot5"/>
           <p:cNvSpPr/>
           <p:nvPr/>
         </p:nvSpPr>
@@ -9223,7 +9259,7 @@
       </p:sp>
       <p:pic>
         <p:nvPicPr>
-          <p:cNvPr id="32" name="Image 5" descr="preencoded.png">    </p:cNvPr>
+          <p:cNvPr id="32" name="!!ico5" descr="preencoded.png">    </p:cNvPr>
           <p:cNvPicPr>
             <a:picLocks noChangeAspect="1"/>
           </p:cNvPicPr>
@@ -9325,7 +9361,7 @@
       </p:sp>
       <p:sp>
         <p:nvSpPr>
-          <p:cNvPr id="35" name="Shape 27"/>
+          <p:cNvPr id="35" name="!!card6"/>
           <p:cNvSpPr/>
           <p:nvPr/>
         </p:nvSpPr>
@@ -9359,7 +9395,7 @@
       </p:sp>
       <p:sp>
         <p:nvSpPr>
-          <p:cNvPr id="36" name="Shape 28"/>
+          <p:cNvPr id="36" name="!!dot6"/>
           <p:cNvSpPr/>
           <p:nvPr/>
         </p:nvSpPr>
@@ -9384,7 +9420,7 @@
       </p:sp>
       <p:pic>
         <p:nvPicPr>
-          <p:cNvPr id="37" name="Image 6" descr="preencoded.png">    </p:cNvPr>
+          <p:cNvPr id="37" name="!!ico6" descr="preencoded.png">    </p:cNvPr>
           <p:cNvPicPr>
             <a:picLocks noChangeAspect="1"/>
           </p:cNvPicPr>
@@ -9486,7 +9522,7 @@
       </p:sp>
       <p:sp>
         <p:nvSpPr>
-          <p:cNvPr id="40" name="Shape 31"/>
+          <p:cNvPr id="40" name="!!card7"/>
           <p:cNvSpPr/>
           <p:nvPr/>
         </p:nvSpPr>
@@ -9520,7 +9556,7 @@
       </p:sp>
       <p:sp>
         <p:nvSpPr>
-          <p:cNvPr id="41" name="Shape 32"/>
+          <p:cNvPr id="41" name="!!dot7"/>
           <p:cNvSpPr/>
           <p:nvPr/>
         </p:nvSpPr>
@@ -9545,7 +9581,7 @@
       </p:sp>
       <p:pic>
         <p:nvPicPr>
-          <p:cNvPr id="42" name="Image 7" descr="preencoded.png">    </p:cNvPr>
+          <p:cNvPr id="42" name="!!ico7" descr="preencoded.png">    </p:cNvPr>
           <p:cNvPicPr>
             <a:picLocks noChangeAspect="1"/>
           </p:cNvPicPr>
@@ -9647,7 +9683,7 @@
       </p:sp>
       <p:sp>
         <p:nvSpPr>
-          <p:cNvPr id="45" name="Shape 35"/>
+          <p:cNvPr id="45" name="!!card8"/>
           <p:cNvSpPr/>
           <p:nvPr/>
         </p:nvSpPr>
@@ -9681,7 +9717,7 @@
       </p:sp>
       <p:sp>
         <p:nvSpPr>
-          <p:cNvPr id="46" name="Shape 36"/>
+          <p:cNvPr id="46" name="!!dot8"/>
           <p:cNvSpPr/>
           <p:nvPr/>
         </p:nvSpPr>
@@ -9706,7 +9742,7 @@
       </p:sp>
       <p:pic>
         <p:nvPicPr>
-          <p:cNvPr id="47" name="Image 8" descr="preencoded.png">    </p:cNvPr>
+          <p:cNvPr id="47" name="!!ico8" descr="preencoded.png">    </p:cNvPr>
           <p:cNvPicPr>
             <a:picLocks noChangeAspect="1"/>
           </p:cNvPicPr>
@@ -9808,7 +9844,7 @@
       </p:sp>
       <p:sp>
         <p:nvSpPr>
-          <p:cNvPr id="50" name="Shape 39"/>
+          <p:cNvPr id="50" name="!!card9"/>
           <p:cNvSpPr/>
           <p:nvPr/>
         </p:nvSpPr>
@@ -9842,7 +9878,7 @@
       </p:sp>
       <p:sp>
         <p:nvSpPr>
-          <p:cNvPr id="51" name="Shape 40"/>
+          <p:cNvPr id="51" name="!!dot9"/>
           <p:cNvSpPr/>
           <p:nvPr/>
         </p:nvSpPr>
@@ -9867,7 +9903,7 @@
       </p:sp>
       <p:pic>
         <p:nvPicPr>
-          <p:cNvPr id="52" name="Image 9" descr="preencoded.png">    </p:cNvPr>
+          <p:cNvPr id="52" name="!!ico9" descr="preencoded.png">    </p:cNvPr>
           <p:cNvPicPr>
             <a:picLocks noChangeAspect="1"/>
           </p:cNvPicPr>
@@ -10084,6 +10120,18 @@
   <p:clrMapOvr>
     <a:masterClrMapping/>
   </p:clrMapOvr>
+  <mc:AlternateContent xmlns:mc="http://schemas.openxmlformats.org/markup-compatibility/2006">
+    <mc:Choice xmlns:p159="http://schemas.microsoft.com/office/powerpoint/2015/09/main" Requires="p159">
+      <p:transition xmlns:p14="http://schemas.microsoft.com/office/powerpoint/2010/main" spd="slow" p14:dur="1250">
+        <p159:morph option="byObject"/>
+      </p:transition>
+    </mc:Choice>
+    <mc:Fallback>
+      <p:transition spd="slow">
+        <p:fade/>
+      </p:transition>
+    </mc:Fallback>
+  </mc:AlternateContent>
 </p:sld>
 </file>
 
@@ -19227,7 +19275,7 @@
       </p:graphicFrame>
       <p:sp>
         <p:nvSpPr>
-          <p:cNvPr id="5" name="Shape 2"/>
+          <p:cNvPr id="5" name="!!card0"/>
           <p:cNvSpPr/>
           <p:nvPr/>
         </p:nvSpPr>
@@ -19368,6 +19416,18 @@
   <p:clrMapOvr>
     <a:masterClrMapping/>
   </p:clrMapOvr>
+  <mc:AlternateContent xmlns:mc="http://schemas.openxmlformats.org/markup-compatibility/2006">
+    <mc:Choice xmlns:p159="http://schemas.microsoft.com/office/powerpoint/2015/09/main" Requires="p159">
+      <p:transition xmlns:p14="http://schemas.microsoft.com/office/powerpoint/2010/main" spd="slow" p14:dur="1250">
+        <p159:morph option="byObject"/>
+      </p:transition>
+    </mc:Choice>
+    <mc:Fallback>
+      <p:transition spd="slow">
+        <p:fade/>
+      </p:transition>
+    </mc:Fallback>
+  </mc:AlternateContent>
 </p:sld>
 </file>
 
@@ -25754,7 +25814,7 @@
       </p:graphicFrame>
       <p:sp>
         <p:nvSpPr>
-          <p:cNvPr id="6" name="Shape 3"/>
+          <p:cNvPr id="6" name="!!card0"/>
           <p:cNvSpPr/>
           <p:nvPr/>
         </p:nvSpPr>
@@ -25788,7 +25848,7 @@
       </p:sp>
       <p:sp>
         <p:nvSpPr>
-          <p:cNvPr id="7" name="Shape 4"/>
+          <p:cNvPr id="7" name="!!dot0"/>
           <p:cNvSpPr/>
           <p:nvPr/>
         </p:nvSpPr>
@@ -25813,7 +25873,7 @@
       </p:sp>
       <p:pic>
         <p:nvPicPr>
-          <p:cNvPr id="8" name="Image 0" descr="preencoded.png">    </p:cNvPr>
+          <p:cNvPr id="8" name="!!ico0" descr="preencoded.png">    </p:cNvPr>
           <p:cNvPicPr>
             <a:picLocks noChangeAspect="1"/>
           </p:cNvPicPr>
@@ -25915,7 +25975,7 @@
       </p:sp>
       <p:sp>
         <p:nvSpPr>
-          <p:cNvPr id="11" name="Shape 7"/>
+          <p:cNvPr id="11" name="!!card1"/>
           <p:cNvSpPr/>
           <p:nvPr/>
         </p:nvSpPr>
@@ -25949,7 +26009,7 @@
       </p:sp>
       <p:sp>
         <p:nvSpPr>
-          <p:cNvPr id="12" name="Shape 8"/>
+          <p:cNvPr id="12" name="!!dot1"/>
           <p:cNvSpPr/>
           <p:nvPr/>
         </p:nvSpPr>
@@ -25974,7 +26034,7 @@
       </p:sp>
       <p:pic>
         <p:nvPicPr>
-          <p:cNvPr id="13" name="Image 1" descr="preencoded.png">    </p:cNvPr>
+          <p:cNvPr id="13" name="!!ico1" descr="preencoded.png">    </p:cNvPr>
           <p:cNvPicPr>
             <a:picLocks noChangeAspect="1"/>
           </p:cNvPicPr>
@@ -26076,7 +26136,7 @@
       </p:sp>
       <p:sp>
         <p:nvSpPr>
-          <p:cNvPr id="16" name="Shape 11"/>
+          <p:cNvPr id="16" name="!!card2"/>
           <p:cNvSpPr/>
           <p:nvPr/>
         </p:nvSpPr>
@@ -26110,7 +26170,7 @@
       </p:sp>
       <p:sp>
         <p:nvSpPr>
-          <p:cNvPr id="17" name="Shape 12"/>
+          <p:cNvPr id="17" name="!!dot2"/>
           <p:cNvSpPr/>
           <p:nvPr/>
         </p:nvSpPr>
@@ -26135,7 +26195,7 @@
       </p:sp>
       <p:pic>
         <p:nvPicPr>
-          <p:cNvPr id="18" name="Image 2" descr="preencoded.png">    </p:cNvPr>
+          <p:cNvPr id="18" name="!!ico2" descr="preencoded.png">    </p:cNvPr>
           <p:cNvPicPr>
             <a:picLocks noChangeAspect="1"/>
           </p:cNvPicPr>
@@ -26327,6 +26387,18 @@
   <p:clrMapOvr>
     <a:masterClrMapping/>
   </p:clrMapOvr>
+  <mc:AlternateContent xmlns:mc="http://schemas.openxmlformats.org/markup-compatibility/2006">
+    <mc:Choice xmlns:p159="http://schemas.microsoft.com/office/powerpoint/2015/09/main" Requires="p159">
+      <p:transition xmlns:p14="http://schemas.microsoft.com/office/powerpoint/2010/main" spd="slow" p14:dur="1250">
+        <p159:morph option="byObject"/>
+      </p:transition>
+    </mc:Choice>
+    <mc:Fallback>
+      <p:transition spd="slow">
+        <p:fade/>
+      </p:transition>
+    </mc:Fallback>
+  </mc:AlternateContent>
 </p:sld>
 </file>
 
@@ -26431,7 +26503,7 @@
       </p:sp>
       <p:sp>
         <p:nvSpPr>
-          <p:cNvPr id="4" name="Shape 2"/>
+          <p:cNvPr id="4" name="!!card0"/>
           <p:cNvSpPr/>
           <p:nvPr/>
         </p:nvSpPr>
@@ -26559,7 +26631,7 @@
       </p:sp>
       <p:sp>
         <p:nvSpPr>
-          <p:cNvPr id="8" name="Shape 5"/>
+          <p:cNvPr id="8" name="!!dot0"/>
           <p:cNvSpPr/>
           <p:nvPr/>
         </p:nvSpPr>
@@ -26584,7 +26656,7 @@
       </p:sp>
       <p:pic>
         <p:nvPicPr>
-          <p:cNvPr id="9" name="Image 0" descr="preencoded.png">    </p:cNvPr>
+          <p:cNvPr id="9" name="!!ico0" descr="preencoded.png">    </p:cNvPr>
           <p:cNvPicPr>
             <a:picLocks noChangeAspect="1"/>
           </p:cNvPicPr>
@@ -26647,7 +26719,7 @@
       </p:sp>
       <p:sp>
         <p:nvSpPr>
-          <p:cNvPr id="11" name="Shape 7"/>
+          <p:cNvPr id="11" name="!!dot1"/>
           <p:cNvSpPr/>
           <p:nvPr/>
         </p:nvSpPr>
@@ -26672,7 +26744,7 @@
       </p:sp>
       <p:pic>
         <p:nvPicPr>
-          <p:cNvPr id="12" name="Image 1" descr="preencoded.png">    </p:cNvPr>
+          <p:cNvPr id="12" name="!!ico1" descr="preencoded.png">    </p:cNvPr>
           <p:cNvPicPr>
             <a:picLocks noChangeAspect="1"/>
           </p:cNvPicPr>
@@ -26735,7 +26807,7 @@
       </p:sp>
       <p:sp>
         <p:nvSpPr>
-          <p:cNvPr id="14" name="Shape 9"/>
+          <p:cNvPr id="14" name="!!dot2"/>
           <p:cNvSpPr/>
           <p:nvPr/>
         </p:nvSpPr>
@@ -26760,7 +26832,7 @@
       </p:sp>
       <p:pic>
         <p:nvPicPr>
-          <p:cNvPr id="15" name="Image 2" descr="preencoded.png">    </p:cNvPr>
+          <p:cNvPr id="15" name="!!ico2" descr="preencoded.png">    </p:cNvPr>
           <p:cNvPicPr>
             <a:picLocks noChangeAspect="1"/>
           </p:cNvPicPr>
@@ -26823,7 +26895,7 @@
       </p:sp>
       <p:sp>
         <p:nvSpPr>
-          <p:cNvPr id="17" name="Shape 11"/>
+          <p:cNvPr id="17" name="!!dot3"/>
           <p:cNvSpPr/>
           <p:nvPr/>
         </p:nvSpPr>
@@ -26848,7 +26920,7 @@
       </p:sp>
       <p:pic>
         <p:nvPicPr>
-          <p:cNvPr id="18" name="Image 3" descr="preencoded.png">    </p:cNvPr>
+          <p:cNvPr id="18" name="!!ico3" descr="preencoded.png">    </p:cNvPr>
           <p:cNvPicPr>
             <a:picLocks noChangeAspect="1"/>
           </p:cNvPicPr>
@@ -26911,7 +26983,7 @@
       </p:sp>
       <p:sp>
         <p:nvSpPr>
-          <p:cNvPr id="20" name="Shape 13"/>
+          <p:cNvPr id="20" name="!!dot4"/>
           <p:cNvSpPr/>
           <p:nvPr/>
         </p:nvSpPr>
@@ -26936,7 +27008,7 @@
       </p:sp>
       <p:pic>
         <p:nvPicPr>
-          <p:cNvPr id="21" name="Image 4" descr="preencoded.png">    </p:cNvPr>
+          <p:cNvPr id="21" name="!!ico4" descr="preencoded.png">    </p:cNvPr>
           <p:cNvPicPr>
             <a:picLocks noChangeAspect="1"/>
           </p:cNvPicPr>
@@ -26999,7 +27071,7 @@
       </p:sp>
       <p:sp>
         <p:nvSpPr>
-          <p:cNvPr id="23" name="Shape 15"/>
+          <p:cNvPr id="23" name="!!dot5"/>
           <p:cNvSpPr/>
           <p:nvPr/>
         </p:nvSpPr>
@@ -27024,7 +27096,7 @@
       </p:sp>
       <p:pic>
         <p:nvPicPr>
-          <p:cNvPr id="24" name="Image 5" descr="preencoded.png">    </p:cNvPr>
+          <p:cNvPr id="24" name="!!ico5" descr="preencoded.png">    </p:cNvPr>
           <p:cNvPicPr>
             <a:picLocks noChangeAspect="1"/>
           </p:cNvPicPr>
@@ -27087,7 +27159,7 @@
       </p:sp>
       <p:sp>
         <p:nvSpPr>
-          <p:cNvPr id="26" name="Shape 17"/>
+          <p:cNvPr id="26" name="!!dot6"/>
           <p:cNvSpPr/>
           <p:nvPr/>
         </p:nvSpPr>
@@ -27112,7 +27184,7 @@
       </p:sp>
       <p:pic>
         <p:nvPicPr>
-          <p:cNvPr id="27" name="Image 6" descr="preencoded.png">    </p:cNvPr>
+          <p:cNvPr id="27" name="!!ico6" descr="preencoded.png">    </p:cNvPr>
           <p:cNvPicPr>
             <a:picLocks noChangeAspect="1"/>
           </p:cNvPicPr>
@@ -27175,7 +27247,7 @@
       </p:sp>
       <p:sp>
         <p:nvSpPr>
-          <p:cNvPr id="29" name="Shape 19"/>
+          <p:cNvPr id="29" name="!!card1"/>
           <p:cNvSpPr/>
           <p:nvPr/>
         </p:nvSpPr>
@@ -27345,6 +27417,18 @@
   <p:clrMapOvr>
     <a:masterClrMapping/>
   </p:clrMapOvr>
+  <mc:AlternateContent xmlns:mc="http://schemas.openxmlformats.org/markup-compatibility/2006">
+    <mc:Choice xmlns:p159="http://schemas.microsoft.com/office/powerpoint/2015/09/main" Requires="p159">
+      <p:transition xmlns:p14="http://schemas.microsoft.com/office/powerpoint/2010/main" spd="slow" p14:dur="1250">
+        <p159:morph option="byObject"/>
+      </p:transition>
+    </mc:Choice>
+    <mc:Fallback>
+      <p:transition spd="slow">
+        <p:fade/>
+      </p:transition>
+    </mc:Fallback>
+  </mc:AlternateContent>
 </p:sld>
 </file>
 
@@ -27488,7 +27572,7 @@
       </p:sp>
       <p:sp>
         <p:nvSpPr>
-          <p:cNvPr id="5" name="Shape 3"/>
+          <p:cNvPr id="5" name="!!card0"/>
           <p:cNvSpPr/>
           <p:nvPr/>
         </p:nvSpPr>
@@ -27522,7 +27606,7 @@
       </p:sp>
       <p:sp>
         <p:nvSpPr>
-          <p:cNvPr id="6" name="Shape 4"/>
+          <p:cNvPr id="6" name="!!dot0"/>
           <p:cNvSpPr/>
           <p:nvPr/>
         </p:nvSpPr>
@@ -27547,7 +27631,7 @@
       </p:sp>
       <p:pic>
         <p:nvPicPr>
-          <p:cNvPr id="7" name="Image 0" descr="preencoded.png">    </p:cNvPr>
+          <p:cNvPr id="7" name="!!ico0" descr="preencoded.png">    </p:cNvPr>
           <p:cNvPicPr>
             <a:picLocks noChangeAspect="1"/>
           </p:cNvPicPr>
@@ -27663,7 +27747,7 @@
       </p:sp>
       <p:sp>
         <p:nvSpPr>
-          <p:cNvPr id="10" name="Shape 7"/>
+          <p:cNvPr id="10" name="!!card1"/>
           <p:cNvSpPr/>
           <p:nvPr/>
         </p:nvSpPr>
@@ -27697,7 +27781,7 @@
       </p:sp>
       <p:sp>
         <p:nvSpPr>
-          <p:cNvPr id="11" name="Shape 8"/>
+          <p:cNvPr id="11" name="!!dot1"/>
           <p:cNvSpPr/>
           <p:nvPr/>
         </p:nvSpPr>
@@ -27722,7 +27806,7 @@
       </p:sp>
       <p:pic>
         <p:nvPicPr>
-          <p:cNvPr id="12" name="Image 1" descr="preencoded.png">    </p:cNvPr>
+          <p:cNvPr id="12" name="!!ico1" descr="preencoded.png">    </p:cNvPr>
           <p:cNvPicPr>
             <a:picLocks noChangeAspect="1"/>
           </p:cNvPicPr>
@@ -27838,7 +27922,7 @@
       </p:sp>
       <p:sp>
         <p:nvSpPr>
-          <p:cNvPr id="15" name="Shape 11"/>
+          <p:cNvPr id="15" name="!!card2"/>
           <p:cNvSpPr/>
           <p:nvPr/>
         </p:nvSpPr>
@@ -27872,7 +27956,7 @@
       </p:sp>
       <p:sp>
         <p:nvSpPr>
-          <p:cNvPr id="16" name="Shape 12"/>
+          <p:cNvPr id="16" name="!!dot2"/>
           <p:cNvSpPr/>
           <p:nvPr/>
         </p:nvSpPr>
@@ -27897,7 +27981,7 @@
       </p:sp>
       <p:pic>
         <p:nvPicPr>
-          <p:cNvPr id="17" name="Image 2" descr="preencoded.png">    </p:cNvPr>
+          <p:cNvPr id="17" name="!!ico2" descr="preencoded.png">    </p:cNvPr>
           <p:cNvPicPr>
             <a:picLocks noChangeAspect="1"/>
           </p:cNvPicPr>
@@ -28013,7 +28097,7 @@
       </p:sp>
       <p:sp>
         <p:nvSpPr>
-          <p:cNvPr id="20" name="Shape 15"/>
+          <p:cNvPr id="20" name="!!card3"/>
           <p:cNvSpPr/>
           <p:nvPr/>
         </p:nvSpPr>
@@ -28047,7 +28131,7 @@
       </p:sp>
       <p:sp>
         <p:nvSpPr>
-          <p:cNvPr id="21" name="Shape 16"/>
+          <p:cNvPr id="21" name="!!dot3"/>
           <p:cNvSpPr/>
           <p:nvPr/>
         </p:nvSpPr>
@@ -28072,7 +28156,7 @@
       </p:sp>
       <p:pic>
         <p:nvPicPr>
-          <p:cNvPr id="22" name="Image 3" descr="preencoded.png">    </p:cNvPr>
+          <p:cNvPr id="22" name="!!ico3" descr="preencoded.png">    </p:cNvPr>
           <p:cNvPicPr>
             <a:picLocks noChangeAspect="1"/>
           </p:cNvPicPr>
@@ -28188,7 +28272,7 @@
       </p:sp>
       <p:sp>
         <p:nvSpPr>
-          <p:cNvPr id="25" name="Shape 19"/>
+          <p:cNvPr id="25" name="!!card4"/>
           <p:cNvSpPr/>
           <p:nvPr/>
         </p:nvSpPr>
@@ -28222,7 +28306,7 @@
       </p:sp>
       <p:sp>
         <p:nvSpPr>
-          <p:cNvPr id="26" name="Shape 20"/>
+          <p:cNvPr id="26" name="!!dot4"/>
           <p:cNvSpPr/>
           <p:nvPr/>
         </p:nvSpPr>
@@ -28247,7 +28331,7 @@
       </p:sp>
       <p:pic>
         <p:nvPicPr>
-          <p:cNvPr id="27" name="Image 4" descr="preencoded.png">    </p:cNvPr>
+          <p:cNvPr id="27" name="!!ico4" descr="preencoded.png">    </p:cNvPr>
           <p:cNvPicPr>
             <a:picLocks noChangeAspect="1"/>
           </p:cNvPicPr>
@@ -28363,7 +28447,7 @@
       </p:sp>
       <p:sp>
         <p:nvSpPr>
-          <p:cNvPr id="30" name="Shape 23"/>
+          <p:cNvPr id="30" name="!!card5"/>
           <p:cNvSpPr/>
           <p:nvPr/>
         </p:nvSpPr>
@@ -28397,7 +28481,7 @@
       </p:sp>
       <p:sp>
         <p:nvSpPr>
-          <p:cNvPr id="31" name="Shape 24"/>
+          <p:cNvPr id="31" name="!!dot5"/>
           <p:cNvSpPr/>
           <p:nvPr/>
         </p:nvSpPr>
@@ -28422,7 +28506,7 @@
       </p:sp>
       <p:pic>
         <p:nvPicPr>
-          <p:cNvPr id="32" name="Image 5" descr="preencoded.png">    </p:cNvPr>
+          <p:cNvPr id="32" name="!!ico5" descr="preencoded.png">    </p:cNvPr>
           <p:cNvPicPr>
             <a:picLocks noChangeAspect="1"/>
           </p:cNvPicPr>
@@ -28628,6 +28712,18 @@
   <p:clrMapOvr>
     <a:masterClrMapping/>
   </p:clrMapOvr>
+  <mc:AlternateContent xmlns:mc="http://schemas.openxmlformats.org/markup-compatibility/2006">
+    <mc:Choice xmlns:p159="http://schemas.microsoft.com/office/powerpoint/2015/09/main" Requires="p159">
+      <p:transition xmlns:p14="http://schemas.microsoft.com/office/powerpoint/2010/main" spd="slow" p14:dur="1250">
+        <p159:morph option="byObject"/>
+      </p:transition>
+    </mc:Choice>
+    <mc:Fallback>
+      <p:transition spd="slow">
+        <p:fade/>
+      </p:transition>
+    </mc:Fallback>
+  </mc:AlternateContent>
 </p:sld>
 </file>
 
@@ -28732,7 +28828,7 @@
       </p:sp>
       <p:sp>
         <p:nvSpPr>
-          <p:cNvPr id="4" name="Shape 2"/>
+          <p:cNvPr id="4" name="!!card0"/>
           <p:cNvSpPr/>
           <p:nvPr/>
         </p:nvSpPr>
@@ -28759,7 +28855,7 @@
       </p:sp>
       <p:sp>
         <p:nvSpPr>
-          <p:cNvPr id="5" name="Shape 3"/>
+          <p:cNvPr id="5" name="!!dot0"/>
           <p:cNvSpPr/>
           <p:nvPr/>
         </p:nvSpPr>
@@ -28784,7 +28880,7 @@
       </p:sp>
       <p:pic>
         <p:nvPicPr>
-          <p:cNvPr id="6" name="Image 0" descr="preencoded.png">    </p:cNvPr>
+          <p:cNvPr id="6" name="!!ico0" descr="preencoded.png">    </p:cNvPr>
           <p:cNvPicPr>
             <a:picLocks noChangeAspect="1"/>
           </p:cNvPicPr>
@@ -28847,7 +28943,7 @@
       </p:sp>
       <p:sp>
         <p:nvSpPr>
-          <p:cNvPr id="8" name="Shape 5"/>
+          <p:cNvPr id="8" name="!!card1"/>
           <p:cNvSpPr/>
           <p:nvPr/>
         </p:nvSpPr>
@@ -28874,7 +28970,7 @@
       </p:sp>
       <p:sp>
         <p:nvSpPr>
-          <p:cNvPr id="9" name="Shape 6"/>
+          <p:cNvPr id="9" name="!!dot1"/>
           <p:cNvSpPr/>
           <p:nvPr/>
         </p:nvSpPr>
@@ -28899,7 +28995,7 @@
       </p:sp>
       <p:pic>
         <p:nvPicPr>
-          <p:cNvPr id="10" name="Image 1" descr="preencoded.png">    </p:cNvPr>
+          <p:cNvPr id="10" name="!!ico1" descr="preencoded.png">    </p:cNvPr>
           <p:cNvPicPr>
             <a:picLocks noChangeAspect="1"/>
           </p:cNvPicPr>
@@ -28962,7 +29058,7 @@
       </p:sp>
       <p:sp>
         <p:nvSpPr>
-          <p:cNvPr id="12" name="Shape 8"/>
+          <p:cNvPr id="12" name="!!card2"/>
           <p:cNvSpPr/>
           <p:nvPr/>
         </p:nvSpPr>
@@ -28989,7 +29085,7 @@
       </p:sp>
       <p:sp>
         <p:nvSpPr>
-          <p:cNvPr id="13" name="Shape 9"/>
+          <p:cNvPr id="13" name="!!dot2"/>
           <p:cNvSpPr/>
           <p:nvPr/>
         </p:nvSpPr>
@@ -29014,7 +29110,7 @@
       </p:sp>
       <p:pic>
         <p:nvPicPr>
-          <p:cNvPr id="14" name="Image 2" descr="preencoded.png">    </p:cNvPr>
+          <p:cNvPr id="14" name="!!ico2" descr="preencoded.png">    </p:cNvPr>
           <p:cNvPicPr>
             <a:picLocks noChangeAspect="1"/>
           </p:cNvPicPr>
@@ -29077,7 +29173,7 @@
       </p:sp>
       <p:sp>
         <p:nvSpPr>
-          <p:cNvPr id="16" name="Shape 11"/>
+          <p:cNvPr id="16" name="!!card3"/>
           <p:cNvSpPr/>
           <p:nvPr/>
         </p:nvSpPr>
@@ -29104,7 +29200,7 @@
       </p:sp>
       <p:sp>
         <p:nvSpPr>
-          <p:cNvPr id="17" name="Shape 12"/>
+          <p:cNvPr id="17" name="!!dot3"/>
           <p:cNvSpPr/>
           <p:nvPr/>
         </p:nvSpPr>
@@ -29129,7 +29225,7 @@
       </p:sp>
       <p:pic>
         <p:nvPicPr>
-          <p:cNvPr id="18" name="Image 3" descr="preencoded.png">    </p:cNvPr>
+          <p:cNvPr id="18" name="!!ico3" descr="preencoded.png">    </p:cNvPr>
           <p:cNvPicPr>
             <a:picLocks noChangeAspect="1"/>
           </p:cNvPicPr>
@@ -29192,7 +29288,7 @@
       </p:sp>
       <p:sp>
         <p:nvSpPr>
-          <p:cNvPr id="20" name="Shape 14"/>
+          <p:cNvPr id="20" name="!!card4"/>
           <p:cNvSpPr/>
           <p:nvPr/>
         </p:nvSpPr>
@@ -29219,7 +29315,7 @@
       </p:sp>
       <p:sp>
         <p:nvSpPr>
-          <p:cNvPr id="21" name="Shape 15"/>
+          <p:cNvPr id="21" name="!!dot4"/>
           <p:cNvSpPr/>
           <p:nvPr/>
         </p:nvSpPr>
@@ -29244,7 +29340,7 @@
       </p:sp>
       <p:pic>
         <p:nvPicPr>
-          <p:cNvPr id="22" name="Image 4" descr="preencoded.png">    </p:cNvPr>
+          <p:cNvPr id="22" name="!!ico4" descr="preencoded.png">    </p:cNvPr>
           <p:cNvPicPr>
             <a:picLocks noChangeAspect="1"/>
           </p:cNvPicPr>
@@ -29307,7 +29403,7 @@
       </p:sp>
       <p:sp>
         <p:nvSpPr>
-          <p:cNvPr id="24" name="Shape 17"/>
+          <p:cNvPr id="24" name="!!card5"/>
           <p:cNvSpPr/>
           <p:nvPr/>
         </p:nvSpPr>
@@ -29334,7 +29430,7 @@
       </p:sp>
       <p:sp>
         <p:nvSpPr>
-          <p:cNvPr id="25" name="Shape 18"/>
+          <p:cNvPr id="25" name="!!dot5"/>
           <p:cNvSpPr/>
           <p:nvPr/>
         </p:nvSpPr>
@@ -29359,7 +29455,7 @@
       </p:sp>
       <p:pic>
         <p:nvPicPr>
-          <p:cNvPr id="26" name="Image 5" descr="preencoded.png">    </p:cNvPr>
+          <p:cNvPr id="26" name="!!ico5" descr="preencoded.png">    </p:cNvPr>
           <p:cNvPicPr>
             <a:picLocks noChangeAspect="1"/>
           </p:cNvPicPr>
@@ -29515,6 +29611,18 @@
   <p:clrMapOvr>
     <a:masterClrMapping/>
   </p:clrMapOvr>
+  <mc:AlternateContent xmlns:mc="http://schemas.openxmlformats.org/markup-compatibility/2006">
+    <mc:Choice xmlns:p159="http://schemas.microsoft.com/office/powerpoint/2015/09/main" Requires="p159">
+      <p:transition xmlns:p14="http://schemas.microsoft.com/office/powerpoint/2010/main" spd="slow" p14:dur="1250">
+        <p159:morph option="byObject"/>
+      </p:transition>
+    </mc:Choice>
+    <mc:Fallback>
+      <p:transition spd="slow">
+        <p:fade/>
+      </p:transition>
+    </mc:Fallback>
+  </mc:AlternateContent>
 </p:sld>
 </file>
 
@@ -29658,7 +29766,7 @@
       </p:sp>
       <p:sp>
         <p:nvSpPr>
-          <p:cNvPr id="5" name="Shape 3"/>
+          <p:cNvPr id="5" name="!!card0"/>
           <p:cNvSpPr/>
           <p:nvPr/>
         </p:nvSpPr>
@@ -30014,7 +30122,7 @@
       </p:sp>
       <p:sp>
         <p:nvSpPr>
-          <p:cNvPr id="16" name="Shape 12"/>
+          <p:cNvPr id="16" name="!!card1"/>
           <p:cNvSpPr/>
           <p:nvPr/>
         </p:nvSpPr>
@@ -30370,7 +30478,7 @@
       </p:sp>
       <p:sp>
         <p:nvSpPr>
-          <p:cNvPr id="27" name="Shape 21"/>
+          <p:cNvPr id="27" name="!!card2"/>
           <p:cNvSpPr/>
           <p:nvPr/>
         </p:nvSpPr>
@@ -30726,7 +30834,7 @@
       </p:sp>
       <p:sp>
         <p:nvSpPr>
-          <p:cNvPr id="38" name="Shape 30"/>
+          <p:cNvPr id="38" name="!!card3"/>
           <p:cNvSpPr/>
           <p:nvPr/>
         </p:nvSpPr>
@@ -31082,7 +31190,7 @@
       </p:sp>
       <p:sp>
         <p:nvSpPr>
-          <p:cNvPr id="49" name="Shape 39"/>
+          <p:cNvPr id="49" name="!!card4"/>
           <p:cNvSpPr/>
           <p:nvPr/>
         </p:nvSpPr>
@@ -31109,7 +31217,7 @@
       </p:sp>
       <p:sp>
         <p:nvSpPr>
-          <p:cNvPr id="50" name="Shape 40"/>
+          <p:cNvPr id="50" name="!!dot0"/>
           <p:cNvSpPr/>
           <p:nvPr/>
         </p:nvSpPr>
@@ -31134,7 +31242,7 @@
       </p:sp>
       <p:pic>
         <p:nvPicPr>
-          <p:cNvPr id="51" name="Image 8" descr="preencoded.png">    </p:cNvPr>
+          <p:cNvPr id="51" name="!!ico0" descr="preencoded.png">    </p:cNvPr>
           <p:cNvPicPr>
             <a:picLocks noChangeAspect="1"/>
           </p:cNvPicPr>
@@ -31763,6 +31871,18 @@
   <p:clrMapOvr>
     <a:masterClrMapping/>
   </p:clrMapOvr>
+  <mc:AlternateContent xmlns:mc="http://schemas.openxmlformats.org/markup-compatibility/2006">
+    <mc:Choice xmlns:p159="http://schemas.microsoft.com/office/powerpoint/2015/09/main" Requires="p159">
+      <p:transition xmlns:p14="http://schemas.microsoft.com/office/powerpoint/2010/main" spd="slow" p14:dur="1250">
+        <p159:morph option="byObject"/>
+      </p:transition>
+    </mc:Choice>
+    <mc:Fallback>
+      <p:transition spd="slow">
+        <p:fade/>
+      </p:transition>
+    </mc:Fallback>
+  </mc:AlternateContent>
 </p:sld>
 </file>
 
@@ -31867,7 +31987,7 @@
       </p:sp>
       <p:sp>
         <p:nvSpPr>
-          <p:cNvPr id="4" name="Shape 2"/>
+          <p:cNvPr id="4" name="!!card0"/>
           <p:cNvSpPr/>
           <p:nvPr/>
         </p:nvSpPr>
@@ -31901,7 +32021,7 @@
       </p:sp>
       <p:sp>
         <p:nvSpPr>
-          <p:cNvPr id="5" name="Shape 3"/>
+          <p:cNvPr id="5" name="!!dot0"/>
           <p:cNvSpPr/>
           <p:nvPr/>
         </p:nvSpPr>
@@ -31926,7 +32046,7 @@
       </p:sp>
       <p:pic>
         <p:nvPicPr>
-          <p:cNvPr id="6" name="Image 0" descr="preencoded.png">    </p:cNvPr>
+          <p:cNvPr id="6" name="!!ico0" descr="preencoded.png">    </p:cNvPr>
           <p:cNvPicPr>
             <a:picLocks noChangeAspect="1"/>
           </p:cNvPicPr>
@@ -32070,7 +32190,7 @@
       </p:sp>
       <p:sp>
         <p:nvSpPr>
-          <p:cNvPr id="10" name="Shape 7"/>
+          <p:cNvPr id="10" name="!!card1"/>
           <p:cNvSpPr/>
           <p:nvPr/>
         </p:nvSpPr>
@@ -32104,7 +32224,7 @@
       </p:sp>
       <p:sp>
         <p:nvSpPr>
-          <p:cNvPr id="11" name="Shape 8"/>
+          <p:cNvPr id="11" name="!!dot1"/>
           <p:cNvSpPr/>
           <p:nvPr/>
         </p:nvSpPr>
@@ -32129,7 +32249,7 @@
       </p:sp>
       <p:pic>
         <p:nvPicPr>
-          <p:cNvPr id="12" name="Image 1" descr="preencoded.png">    </p:cNvPr>
+          <p:cNvPr id="12" name="!!ico1" descr="preencoded.png">    </p:cNvPr>
           <p:cNvPicPr>
             <a:picLocks noChangeAspect="1"/>
           </p:cNvPicPr>
@@ -32273,7 +32393,7 @@
       </p:sp>
       <p:sp>
         <p:nvSpPr>
-          <p:cNvPr id="16" name="Shape 12"/>
+          <p:cNvPr id="16" name="!!card2"/>
           <p:cNvSpPr/>
           <p:nvPr/>
         </p:nvSpPr>
@@ -32307,7 +32427,7 @@
       </p:sp>
       <p:sp>
         <p:nvSpPr>
-          <p:cNvPr id="17" name="Shape 13"/>
+          <p:cNvPr id="17" name="!!dot2"/>
           <p:cNvSpPr/>
           <p:nvPr/>
         </p:nvSpPr>
@@ -32332,7 +32452,7 @@
       </p:sp>
       <p:pic>
         <p:nvPicPr>
-          <p:cNvPr id="18" name="Image 2" descr="preencoded.png">    </p:cNvPr>
+          <p:cNvPr id="18" name="!!ico2" descr="preencoded.png">    </p:cNvPr>
           <p:cNvPicPr>
             <a:picLocks noChangeAspect="1"/>
           </p:cNvPicPr>
@@ -32476,7 +32596,7 @@
       </p:sp>
       <p:sp>
         <p:nvSpPr>
-          <p:cNvPr id="22" name="Shape 17"/>
+          <p:cNvPr id="22" name="!!card3"/>
           <p:cNvSpPr/>
           <p:nvPr/>
         </p:nvSpPr>
@@ -32510,7 +32630,7 @@
       </p:sp>
       <p:sp>
         <p:nvSpPr>
-          <p:cNvPr id="23" name="Shape 18"/>
+          <p:cNvPr id="23" name="!!dot3"/>
           <p:cNvSpPr/>
           <p:nvPr/>
         </p:nvSpPr>
@@ -32535,7 +32655,7 @@
       </p:sp>
       <p:pic>
         <p:nvPicPr>
-          <p:cNvPr id="24" name="Image 3" descr="preencoded.png">    </p:cNvPr>
+          <p:cNvPr id="24" name="!!ico3" descr="preencoded.png">    </p:cNvPr>
           <p:cNvPicPr>
             <a:picLocks noChangeAspect="1"/>
           </p:cNvPicPr>
@@ -32730,6 +32850,18 @@
   <p:clrMapOvr>
     <a:masterClrMapping/>
   </p:clrMapOvr>
+  <mc:AlternateContent xmlns:mc="http://schemas.openxmlformats.org/markup-compatibility/2006">
+    <mc:Choice xmlns:p159="http://schemas.microsoft.com/office/powerpoint/2015/09/main" Requires="p159">
+      <p:transition xmlns:p14="http://schemas.microsoft.com/office/powerpoint/2010/main" spd="slow" p14:dur="1250">
+        <p159:morph option="byObject"/>
+      </p:transition>
+    </mc:Choice>
+    <mc:Fallback>
+      <p:transition spd="slow">
+        <p:fade/>
+      </p:transition>
+    </mc:Fallback>
+  </mc:AlternateContent>
 </p:sld>
 </file>
 
@@ -32834,7 +32966,7 @@
       </p:sp>
       <p:sp>
         <p:nvSpPr>
-          <p:cNvPr id="4" name="Shape 2"/>
+          <p:cNvPr id="4" name="!!card0"/>
           <p:cNvSpPr/>
           <p:nvPr/>
         </p:nvSpPr>
@@ -32963,7 +33095,7 @@
       </p:sp>
       <p:sp>
         <p:nvSpPr>
-          <p:cNvPr id="8" name="Shape 5"/>
+          <p:cNvPr id="8" name="!!card1"/>
           <p:cNvSpPr/>
           <p:nvPr/>
         </p:nvSpPr>
@@ -32990,7 +33122,7 @@
       </p:sp>
       <p:sp>
         <p:nvSpPr>
-          <p:cNvPr id="9" name="Shape 6"/>
+          <p:cNvPr id="9" name="!!dot0"/>
           <p:cNvSpPr/>
           <p:nvPr/>
         </p:nvSpPr>
@@ -33093,7 +33225,7 @@
       </p:sp>
       <p:sp>
         <p:nvSpPr>
-          <p:cNvPr id="12" name="Shape 9"/>
+          <p:cNvPr id="12" name="!!card2"/>
           <p:cNvSpPr/>
           <p:nvPr/>
         </p:nvSpPr>
@@ -33120,7 +33252,7 @@
       </p:sp>
       <p:sp>
         <p:nvSpPr>
-          <p:cNvPr id="13" name="Shape 10"/>
+          <p:cNvPr id="13" name="!!dot1"/>
           <p:cNvSpPr/>
           <p:nvPr/>
         </p:nvSpPr>
@@ -33223,7 +33355,7 @@
       </p:sp>
       <p:sp>
         <p:nvSpPr>
-          <p:cNvPr id="16" name="Shape 13"/>
+          <p:cNvPr id="16" name="!!card3"/>
           <p:cNvSpPr/>
           <p:nvPr/>
         </p:nvSpPr>
@@ -33250,7 +33382,7 @@
       </p:sp>
       <p:sp>
         <p:nvSpPr>
-          <p:cNvPr id="17" name="Shape 14"/>
+          <p:cNvPr id="17" name="!!dot2"/>
           <p:cNvSpPr/>
           <p:nvPr/>
         </p:nvSpPr>
@@ -33353,7 +33485,7 @@
       </p:sp>
       <p:sp>
         <p:nvSpPr>
-          <p:cNvPr id="20" name="Shape 17"/>
+          <p:cNvPr id="20" name="!!card4"/>
           <p:cNvSpPr/>
           <p:nvPr/>
         </p:nvSpPr>
@@ -33380,7 +33512,7 @@
       </p:sp>
       <p:sp>
         <p:nvSpPr>
-          <p:cNvPr id="21" name="Shape 18"/>
+          <p:cNvPr id="21" name="!!dot3"/>
           <p:cNvSpPr/>
           <p:nvPr/>
         </p:nvSpPr>
@@ -33483,7 +33615,7 @@
       </p:sp>
       <p:sp>
         <p:nvSpPr>
-          <p:cNvPr id="24" name="Shape 21"/>
+          <p:cNvPr id="24" name="!!card5"/>
           <p:cNvSpPr/>
           <p:nvPr/>
         </p:nvSpPr>
@@ -33510,7 +33642,7 @@
       </p:sp>
       <p:sp>
         <p:nvSpPr>
-          <p:cNvPr id="25" name="Shape 22"/>
+          <p:cNvPr id="25" name="!!dot4"/>
           <p:cNvSpPr/>
           <p:nvPr/>
         </p:nvSpPr>
@@ -33613,7 +33745,7 @@
       </p:sp>
       <p:sp>
         <p:nvSpPr>
-          <p:cNvPr id="28" name="Shape 25"/>
+          <p:cNvPr id="28" name="!!card6"/>
           <p:cNvSpPr/>
           <p:nvPr/>
         </p:nvSpPr>
@@ -33640,7 +33772,7 @@
       </p:sp>
       <p:sp>
         <p:nvSpPr>
-          <p:cNvPr id="29" name="Shape 26"/>
+          <p:cNvPr id="29" name="!!dot5"/>
           <p:cNvSpPr/>
           <p:nvPr/>
         </p:nvSpPr>
@@ -33743,7 +33875,7 @@
       </p:sp>
       <p:sp>
         <p:nvSpPr>
-          <p:cNvPr id="32" name="Shape 29"/>
+          <p:cNvPr id="32" name="!!card7"/>
           <p:cNvSpPr/>
           <p:nvPr/>
         </p:nvSpPr>
@@ -33770,7 +33902,7 @@
       </p:sp>
       <p:sp>
         <p:nvSpPr>
-          <p:cNvPr id="33" name="Shape 30"/>
+          <p:cNvPr id="33" name="!!dot6"/>
           <p:cNvSpPr/>
           <p:nvPr/>
         </p:nvSpPr>
@@ -33873,7 +34005,7 @@
       </p:sp>
       <p:sp>
         <p:nvSpPr>
-          <p:cNvPr id="36" name="Shape 33"/>
+          <p:cNvPr id="36" name="!!card8"/>
           <p:cNvSpPr/>
           <p:nvPr/>
         </p:nvSpPr>
@@ -33900,7 +34032,7 @@
       </p:sp>
       <p:sp>
         <p:nvSpPr>
-          <p:cNvPr id="37" name="Shape 34"/>
+          <p:cNvPr id="37" name="!!dot7"/>
           <p:cNvSpPr/>
           <p:nvPr/>
         </p:nvSpPr>
@@ -34003,7 +34135,7 @@
       </p:sp>
       <p:sp>
         <p:nvSpPr>
-          <p:cNvPr id="40" name="Shape 37"/>
+          <p:cNvPr id="40" name="!!card9"/>
           <p:cNvSpPr/>
           <p:nvPr/>
         </p:nvSpPr>
@@ -34030,7 +34162,7 @@
       </p:sp>
       <p:sp>
         <p:nvSpPr>
-          <p:cNvPr id="41" name="Shape 38"/>
+          <p:cNvPr id="41" name="!!dot8"/>
           <p:cNvSpPr/>
           <p:nvPr/>
         </p:nvSpPr>
@@ -34133,7 +34265,7 @@
       </p:sp>
       <p:sp>
         <p:nvSpPr>
-          <p:cNvPr id="44" name="Shape 41"/>
+          <p:cNvPr id="44" name="!!card10"/>
           <p:cNvSpPr/>
           <p:nvPr/>
         </p:nvSpPr>
@@ -34160,7 +34292,7 @@
       </p:sp>
       <p:sp>
         <p:nvSpPr>
-          <p:cNvPr id="45" name="Shape 42"/>
+          <p:cNvPr id="45" name="!!dot9"/>
           <p:cNvSpPr/>
           <p:nvPr/>
         </p:nvSpPr>
@@ -34314,6 +34446,18 @@
   <p:clrMapOvr>
     <a:masterClrMapping/>
   </p:clrMapOvr>
+  <mc:AlternateContent xmlns:mc="http://schemas.openxmlformats.org/markup-compatibility/2006">
+    <mc:Choice xmlns:p159="http://schemas.microsoft.com/office/powerpoint/2015/09/main" Requires="p159">
+      <p:transition xmlns:p14="http://schemas.microsoft.com/office/powerpoint/2010/main" spd="slow" p14:dur="1250">
+        <p159:morph option="byObject"/>
+      </p:transition>
+    </mc:Choice>
+    <mc:Fallback>
+      <p:transition spd="slow">
+        <p:fade/>
+      </p:transition>
+    </mc:Fallback>
+  </mc:AlternateContent>
 </p:sld>
 </file>
 
@@ -34418,7 +34562,7 @@
       </p:sp>
       <p:sp>
         <p:nvSpPr>
-          <p:cNvPr id="4" name="Shape 2"/>
+          <p:cNvPr id="4" name="!!card0"/>
           <p:cNvSpPr/>
           <p:nvPr/>
         </p:nvSpPr>
@@ -34452,7 +34596,7 @@
       </p:sp>
       <p:sp>
         <p:nvSpPr>
-          <p:cNvPr id="5" name="Shape 3"/>
+          <p:cNvPr id="5" name="!!dot0"/>
           <p:cNvSpPr/>
           <p:nvPr/>
         </p:nvSpPr>
@@ -34477,7 +34621,7 @@
       </p:sp>
       <p:pic>
         <p:nvPicPr>
-          <p:cNvPr id="6" name="Image 0" descr="preencoded.png">    </p:cNvPr>
+          <p:cNvPr id="6" name="!!ico0" descr="preencoded.png">    </p:cNvPr>
           <p:cNvPicPr>
             <a:picLocks noChangeAspect="1"/>
           </p:cNvPicPr>
@@ -34621,7 +34765,7 @@
       </p:sp>
       <p:sp>
         <p:nvSpPr>
-          <p:cNvPr id="10" name="Shape 7"/>
+          <p:cNvPr id="10" name="!!card1"/>
           <p:cNvSpPr/>
           <p:nvPr/>
         </p:nvSpPr>
@@ -34655,7 +34799,7 @@
       </p:sp>
       <p:sp>
         <p:nvSpPr>
-          <p:cNvPr id="11" name="Shape 8"/>
+          <p:cNvPr id="11" name="!!dot1"/>
           <p:cNvSpPr/>
           <p:nvPr/>
         </p:nvSpPr>
@@ -34680,7 +34824,7 @@
       </p:sp>
       <p:pic>
         <p:nvPicPr>
-          <p:cNvPr id="12" name="Image 1" descr="preencoded.png">    </p:cNvPr>
+          <p:cNvPr id="12" name="!!ico1" descr="preencoded.png">    </p:cNvPr>
           <p:cNvPicPr>
             <a:picLocks noChangeAspect="1"/>
           </p:cNvPicPr>
@@ -34824,7 +34968,7 @@
       </p:sp>
       <p:sp>
         <p:nvSpPr>
-          <p:cNvPr id="16" name="Shape 12"/>
+          <p:cNvPr id="16" name="!!card2"/>
           <p:cNvSpPr/>
           <p:nvPr/>
         </p:nvSpPr>
@@ -34858,7 +35002,7 @@
       </p:sp>
       <p:sp>
         <p:nvSpPr>
-          <p:cNvPr id="17" name="Shape 13"/>
+          <p:cNvPr id="17" name="!!dot2"/>
           <p:cNvSpPr/>
           <p:nvPr/>
         </p:nvSpPr>
@@ -34883,7 +35027,7 @@
       </p:sp>
       <p:pic>
         <p:nvPicPr>
-          <p:cNvPr id="18" name="Image 2" descr="preencoded.png">    </p:cNvPr>
+          <p:cNvPr id="18" name="!!ico2" descr="preencoded.png">    </p:cNvPr>
           <p:cNvPicPr>
             <a:picLocks noChangeAspect="1"/>
           </p:cNvPicPr>
@@ -35027,7 +35171,7 @@
       </p:sp>
       <p:sp>
         <p:nvSpPr>
-          <p:cNvPr id="22" name="Shape 17"/>
+          <p:cNvPr id="22" name="!!card3"/>
           <p:cNvSpPr/>
           <p:nvPr/>
         </p:nvSpPr>
@@ -35061,7 +35205,7 @@
       </p:sp>
       <p:sp>
         <p:nvSpPr>
-          <p:cNvPr id="23" name="Shape 18"/>
+          <p:cNvPr id="23" name="!!dot3"/>
           <p:cNvSpPr/>
           <p:nvPr/>
         </p:nvSpPr>
@@ -35086,7 +35230,7 @@
       </p:sp>
       <p:pic>
         <p:nvPicPr>
-          <p:cNvPr id="24" name="Image 3" descr="preencoded.png">    </p:cNvPr>
+          <p:cNvPr id="24" name="!!ico3" descr="preencoded.png">    </p:cNvPr>
           <p:cNvPicPr>
             <a:picLocks noChangeAspect="1"/>
           </p:cNvPicPr>
@@ -35281,6 +35425,18 @@
   <p:clrMapOvr>
     <a:masterClrMapping/>
   </p:clrMapOvr>
+  <mc:AlternateContent xmlns:mc="http://schemas.openxmlformats.org/markup-compatibility/2006">
+    <mc:Choice xmlns:p159="http://schemas.microsoft.com/office/powerpoint/2015/09/main" Requires="p159">
+      <p:transition xmlns:p14="http://schemas.microsoft.com/office/powerpoint/2010/main" spd="slow" p14:dur="1250">
+        <p159:morph option="byObject"/>
+      </p:transition>
+    </mc:Choice>
+    <mc:Fallback>
+      <p:transition spd="slow">
+        <p:fade/>
+      </p:transition>
+    </mc:Fallback>
+  </mc:AlternateContent>
 </p:sld>
 </file>
 
@@ -35408,7 +35564,7 @@
       </p:sp>
       <p:sp>
         <p:nvSpPr>
-          <p:cNvPr id="5" name="Shape 3"/>
+          <p:cNvPr id="5" name="!!dot0"/>
           <p:cNvSpPr/>
           <p:nvPr/>
         </p:nvSpPr>
@@ -35511,7 +35667,7 @@
       </p:sp>
       <p:sp>
         <p:nvSpPr>
-          <p:cNvPr id="8" name="Shape 6"/>
+          <p:cNvPr id="8" name="!!card0"/>
           <p:cNvSpPr/>
           <p:nvPr/>
         </p:nvSpPr>
@@ -35577,7 +35733,7 @@
       </p:sp>
       <p:sp>
         <p:nvSpPr>
-          <p:cNvPr id="10" name="Shape 8"/>
+          <p:cNvPr id="10" name="!!dot1"/>
           <p:cNvSpPr/>
           <p:nvPr/>
         </p:nvSpPr>
@@ -35680,7 +35836,7 @@
       </p:sp>
       <p:sp>
         <p:nvSpPr>
-          <p:cNvPr id="13" name="Shape 11"/>
+          <p:cNvPr id="13" name="!!card1"/>
           <p:cNvSpPr/>
           <p:nvPr/>
         </p:nvSpPr>
@@ -35746,7 +35902,7 @@
       </p:sp>
       <p:sp>
         <p:nvSpPr>
-          <p:cNvPr id="15" name="Shape 13"/>
+          <p:cNvPr id="15" name="!!dot2"/>
           <p:cNvSpPr/>
           <p:nvPr/>
         </p:nvSpPr>
@@ -35849,7 +36005,7 @@
       </p:sp>
       <p:sp>
         <p:nvSpPr>
-          <p:cNvPr id="18" name="Shape 16"/>
+          <p:cNvPr id="18" name="!!card2"/>
           <p:cNvSpPr/>
           <p:nvPr/>
         </p:nvSpPr>
@@ -35915,7 +36071,7 @@
       </p:sp>
       <p:sp>
         <p:nvSpPr>
-          <p:cNvPr id="20" name="Shape 18"/>
+          <p:cNvPr id="20" name="!!dot3"/>
           <p:cNvSpPr/>
           <p:nvPr/>
         </p:nvSpPr>
@@ -36018,7 +36174,7 @@
       </p:sp>
       <p:sp>
         <p:nvSpPr>
-          <p:cNvPr id="23" name="Shape 21"/>
+          <p:cNvPr id="23" name="!!card3"/>
           <p:cNvSpPr/>
           <p:nvPr/>
         </p:nvSpPr>
@@ -36084,7 +36240,7 @@
       </p:sp>
       <p:sp>
         <p:nvSpPr>
-          <p:cNvPr id="25" name="Shape 23"/>
+          <p:cNvPr id="25" name="!!dot4"/>
           <p:cNvSpPr/>
           <p:nvPr/>
         </p:nvSpPr>
@@ -36187,7 +36343,7 @@
       </p:sp>
       <p:sp>
         <p:nvSpPr>
-          <p:cNvPr id="28" name="Shape 26"/>
+          <p:cNvPr id="28" name="!!card4"/>
           <p:cNvSpPr/>
           <p:nvPr/>
         </p:nvSpPr>
@@ -36253,7 +36409,7 @@
       </p:sp>
       <p:sp>
         <p:nvSpPr>
-          <p:cNvPr id="30" name="Shape 28"/>
+          <p:cNvPr id="30" name="!!dot5"/>
           <p:cNvSpPr/>
           <p:nvPr/>
         </p:nvSpPr>
@@ -36356,7 +36512,7 @@
       </p:sp>
       <p:sp>
         <p:nvSpPr>
-          <p:cNvPr id="33" name="Shape 31"/>
+          <p:cNvPr id="33" name="!!card5"/>
           <p:cNvSpPr/>
           <p:nvPr/>
         </p:nvSpPr>
@@ -36422,7 +36578,7 @@
       </p:sp>
       <p:sp>
         <p:nvSpPr>
-          <p:cNvPr id="35" name="Shape 33"/>
+          <p:cNvPr id="35" name="!!dot6"/>
           <p:cNvSpPr/>
           <p:nvPr/>
         </p:nvSpPr>
@@ -36525,7 +36681,7 @@
       </p:sp>
       <p:sp>
         <p:nvSpPr>
-          <p:cNvPr id="38" name="Shape 36"/>
+          <p:cNvPr id="38" name="!!card6"/>
           <p:cNvSpPr/>
           <p:nvPr/>
         </p:nvSpPr>
@@ -36642,6 +36798,18 @@
   <p:clrMapOvr>
     <a:masterClrMapping/>
   </p:clrMapOvr>
+  <mc:AlternateContent xmlns:mc="http://schemas.openxmlformats.org/markup-compatibility/2006">
+    <mc:Choice xmlns:p159="http://schemas.microsoft.com/office/powerpoint/2015/09/main" Requires="p159">
+      <p:transition xmlns:p14="http://schemas.microsoft.com/office/powerpoint/2010/main" spd="slow" p14:dur="1250">
+        <p159:morph option="byObject"/>
+      </p:transition>
+    </mc:Choice>
+    <mc:Fallback>
+      <p:transition spd="slow">
+        <p:fade/>
+      </p:transition>
+    </mc:Fallback>
+  </mc:AlternateContent>
 </p:sld>
 </file>
 
@@ -37446,6 +37614,18 @@
   <p:clrMapOvr>
     <a:masterClrMapping/>
   </p:clrMapOvr>
+  <mc:AlternateContent xmlns:mc="http://schemas.openxmlformats.org/markup-compatibility/2006">
+    <mc:Choice xmlns:p159="http://schemas.microsoft.com/office/powerpoint/2015/09/main" Requires="p159">
+      <p:transition xmlns:p14="http://schemas.microsoft.com/office/powerpoint/2010/main" spd="slow" p14:dur="1250">
+        <p159:morph option="byObject"/>
+      </p:transition>
+    </mc:Choice>
+    <mc:Fallback>
+      <p:transition spd="slow">
+        <p:fade/>
+      </p:transition>
+    </mc:Fallback>
+  </mc:AlternateContent>
 </p:sld>
 </file>
 
@@ -37468,7 +37648,7 @@
       </p:grpSpPr>
       <p:pic>
         <p:nvPicPr>
-          <p:cNvPr id="2" name="Image 0" descr="assets/logo_white.png">    </p:cNvPr>
+          <p:cNvPr id="2" name="!!heroLogo" descr="assets/logo_white.png">    </p:cNvPr>
           <p:cNvPicPr>
             <a:picLocks noChangeAspect="1"/>
           </p:cNvPicPr>
@@ -37482,8 +37662,8 @@
         </p:blipFill>
         <p:spPr>
           <a:xfrm>
-            <a:off x="9631375" y="502920"/>
-            <a:ext cx="2011680" cy="1155802"/>
+            <a:off x="9265615" y="640080"/>
+            <a:ext cx="2377440" cy="1366114"/>
           </a:xfrm>
           <a:prstGeom prst="rect">
             <a:avLst/>
@@ -37651,6 +37831,18 @@
   <p:clrMapOvr>
     <a:masterClrMapping/>
   </p:clrMapOvr>
+  <mc:AlternateContent xmlns:mc="http://schemas.openxmlformats.org/markup-compatibility/2006">
+    <mc:Choice xmlns:p159="http://schemas.microsoft.com/office/powerpoint/2015/09/main" Requires="p159">
+      <p:transition xmlns:p14="http://schemas.microsoft.com/office/powerpoint/2010/main" spd="slow" p14:dur="1250">
+        <p159:morph option="byObject"/>
+      </p:transition>
+    </mc:Choice>
+    <mc:Fallback>
+      <p:transition spd="slow">
+        <p:fade/>
+      </p:transition>
+    </mc:Fallback>
+  </mc:AlternateContent>
 </p:sld>
 </file>
 
@@ -37755,7 +37947,7 @@
       </p:sp>
       <p:sp>
         <p:nvSpPr>
-          <p:cNvPr id="4" name="Shape 2"/>
+          <p:cNvPr id="4" name="!!card0"/>
           <p:cNvSpPr/>
           <p:nvPr/>
         </p:nvSpPr>
@@ -37937,7 +38129,7 @@
       </p:sp>
       <p:sp>
         <p:nvSpPr>
-          <p:cNvPr id="9" name="Shape 7"/>
+          <p:cNvPr id="9" name="!!dot0"/>
           <p:cNvSpPr/>
           <p:nvPr/>
         </p:nvSpPr>
@@ -37962,7 +38154,7 @@
       </p:sp>
       <p:pic>
         <p:nvPicPr>
-          <p:cNvPr id="10" name="Image 0" descr="preencoded.png">    </p:cNvPr>
+          <p:cNvPr id="10" name="!!ico0" descr="preencoded.png">    </p:cNvPr>
           <p:cNvPicPr>
             <a:picLocks noChangeAspect="1"/>
           </p:cNvPicPr>
@@ -38064,7 +38256,7 @@
       </p:sp>
       <p:sp>
         <p:nvSpPr>
-          <p:cNvPr id="13" name="Shape 10"/>
+          <p:cNvPr id="13" name="!!card1"/>
           <p:cNvSpPr/>
           <p:nvPr/>
         </p:nvSpPr>
@@ -38098,7 +38290,7 @@
       </p:sp>
       <p:sp>
         <p:nvSpPr>
-          <p:cNvPr id="14" name="Shape 11"/>
+          <p:cNvPr id="14" name="!!dot1"/>
           <p:cNvSpPr/>
           <p:nvPr/>
         </p:nvSpPr>
@@ -38123,7 +38315,7 @@
       </p:sp>
       <p:pic>
         <p:nvPicPr>
-          <p:cNvPr id="15" name="Image 1" descr="preencoded.png">    </p:cNvPr>
+          <p:cNvPr id="15" name="!!ico1" descr="preencoded.png">    </p:cNvPr>
           <p:cNvPicPr>
             <a:picLocks noChangeAspect="1"/>
           </p:cNvPicPr>
@@ -38228,7 +38420,7 @@
       </p:sp>
       <p:sp>
         <p:nvSpPr>
-          <p:cNvPr id="18" name="Shape 14"/>
+          <p:cNvPr id="18" name="!!card2"/>
           <p:cNvSpPr/>
           <p:nvPr/>
         </p:nvSpPr>
@@ -38255,7 +38447,7 @@
       </p:sp>
       <p:sp>
         <p:nvSpPr>
-          <p:cNvPr id="19" name="Shape 15"/>
+          <p:cNvPr id="19" name="!!dot2"/>
           <p:cNvSpPr/>
           <p:nvPr/>
         </p:nvSpPr>
@@ -38280,7 +38472,7 @@
       </p:sp>
       <p:pic>
         <p:nvPicPr>
-          <p:cNvPr id="20" name="Image 2" descr="preencoded.png">    </p:cNvPr>
+          <p:cNvPr id="20" name="!!ico2" descr="preencoded.png">    </p:cNvPr>
           <p:cNvPicPr>
             <a:picLocks noChangeAspect="1"/>
           </p:cNvPicPr>
@@ -38436,6 +38628,18 @@
   <p:clrMapOvr>
     <a:masterClrMapping/>
   </p:clrMapOvr>
+  <mc:AlternateContent xmlns:mc="http://schemas.openxmlformats.org/markup-compatibility/2006">
+    <mc:Choice xmlns:p159="http://schemas.microsoft.com/office/powerpoint/2015/09/main" Requires="p159">
+      <p:transition xmlns:p14="http://schemas.microsoft.com/office/powerpoint/2010/main" spd="slow" p14:dur="1250">
+        <p159:morph option="byObject"/>
+      </p:transition>
+    </mc:Choice>
+    <mc:Fallback>
+      <p:transition spd="slow">
+        <p:fade/>
+      </p:transition>
+    </mc:Fallback>
+  </mc:AlternateContent>
 </p:sld>
 </file>
 
@@ -38540,7 +38744,7 @@
       </p:sp>
       <p:sp>
         <p:nvSpPr>
-          <p:cNvPr id="4" name="Shape 2"/>
+          <p:cNvPr id="4" name="!!card0"/>
           <p:cNvSpPr/>
           <p:nvPr/>
         </p:nvSpPr>
@@ -38637,7 +38841,7 @@
       </p:sp>
       <p:sp>
         <p:nvSpPr>
-          <p:cNvPr id="7" name="Shape 4"/>
+          <p:cNvPr id="7" name="!!card1"/>
           <p:cNvSpPr/>
           <p:nvPr/>
         </p:nvSpPr>
@@ -38671,7 +38875,7 @@
       </p:sp>
       <p:sp>
         <p:nvSpPr>
-          <p:cNvPr id="8" name="Shape 5"/>
+          <p:cNvPr id="8" name="!!dot0"/>
           <p:cNvSpPr/>
           <p:nvPr/>
         </p:nvSpPr>
@@ -38696,7 +38900,7 @@
       </p:sp>
       <p:pic>
         <p:nvPicPr>
-          <p:cNvPr id="9" name="Image 1" descr="preencoded.png">    </p:cNvPr>
+          <p:cNvPr id="9" name="!!ico0" descr="preencoded.png">    </p:cNvPr>
           <p:cNvPicPr>
             <a:picLocks noChangeAspect="1"/>
           </p:cNvPicPr>
@@ -38798,7 +39002,7 @@
       </p:sp>
       <p:sp>
         <p:nvSpPr>
-          <p:cNvPr id="12" name="Shape 8"/>
+          <p:cNvPr id="12" name="!!card2"/>
           <p:cNvSpPr/>
           <p:nvPr/>
         </p:nvSpPr>
@@ -38832,7 +39036,7 @@
       </p:sp>
       <p:sp>
         <p:nvSpPr>
-          <p:cNvPr id="13" name="Shape 9"/>
+          <p:cNvPr id="13" name="!!dot1"/>
           <p:cNvSpPr/>
           <p:nvPr/>
         </p:nvSpPr>
@@ -38857,7 +39061,7 @@
       </p:sp>
       <p:pic>
         <p:nvPicPr>
-          <p:cNvPr id="14" name="Image 2" descr="preencoded.png">    </p:cNvPr>
+          <p:cNvPr id="14" name="!!ico1" descr="preencoded.png">    </p:cNvPr>
           <p:cNvPicPr>
             <a:picLocks noChangeAspect="1"/>
           </p:cNvPicPr>
@@ -38959,7 +39163,7 @@
       </p:sp>
       <p:sp>
         <p:nvSpPr>
-          <p:cNvPr id="17" name="Shape 12"/>
+          <p:cNvPr id="17" name="!!card3"/>
           <p:cNvSpPr/>
           <p:nvPr/>
         </p:nvSpPr>
@@ -38993,7 +39197,7 @@
       </p:sp>
       <p:sp>
         <p:nvSpPr>
-          <p:cNvPr id="18" name="Shape 13"/>
+          <p:cNvPr id="18" name="!!dot2"/>
           <p:cNvSpPr/>
           <p:nvPr/>
         </p:nvSpPr>
@@ -39018,7 +39222,7 @@
       </p:sp>
       <p:pic>
         <p:nvPicPr>
-          <p:cNvPr id="19" name="Image 3" descr="preencoded.png">    </p:cNvPr>
+          <p:cNvPr id="19" name="!!ico2" descr="preencoded.png">    </p:cNvPr>
           <p:cNvPicPr>
             <a:picLocks noChangeAspect="1"/>
           </p:cNvPicPr>
@@ -39120,7 +39324,7 @@
       </p:sp>
       <p:sp>
         <p:nvSpPr>
-          <p:cNvPr id="22" name="Shape 16"/>
+          <p:cNvPr id="22" name="!!card4"/>
           <p:cNvSpPr/>
           <p:nvPr/>
         </p:nvSpPr>
@@ -39154,7 +39358,7 @@
       </p:sp>
       <p:sp>
         <p:nvSpPr>
-          <p:cNvPr id="23" name="Shape 17"/>
+          <p:cNvPr id="23" name="!!dot3"/>
           <p:cNvSpPr/>
           <p:nvPr/>
         </p:nvSpPr>
@@ -39179,7 +39383,7 @@
       </p:sp>
       <p:pic>
         <p:nvPicPr>
-          <p:cNvPr id="24" name="Image 4" descr="preencoded.png">    </p:cNvPr>
+          <p:cNvPr id="24" name="!!ico3" descr="preencoded.png">    </p:cNvPr>
           <p:cNvPicPr>
             <a:picLocks noChangeAspect="1"/>
           </p:cNvPicPr>
@@ -39281,7 +39485,7 @@
       </p:sp>
       <p:sp>
         <p:nvSpPr>
-          <p:cNvPr id="27" name="Shape 20"/>
+          <p:cNvPr id="27" name="!!card5"/>
           <p:cNvSpPr/>
           <p:nvPr/>
         </p:nvSpPr>
@@ -39315,7 +39519,7 @@
       </p:sp>
       <p:sp>
         <p:nvSpPr>
-          <p:cNvPr id="28" name="Shape 21"/>
+          <p:cNvPr id="28" name="!!dot4"/>
           <p:cNvSpPr/>
           <p:nvPr/>
         </p:nvSpPr>
@@ -39340,7 +39544,7 @@
       </p:sp>
       <p:pic>
         <p:nvPicPr>
-          <p:cNvPr id="29" name="Image 5" descr="preencoded.png">    </p:cNvPr>
+          <p:cNvPr id="29" name="!!ico4" descr="preencoded.png">    </p:cNvPr>
           <p:cNvPicPr>
             <a:picLocks noChangeAspect="1"/>
           </p:cNvPicPr>
@@ -39493,6 +39697,18 @@
   <p:clrMapOvr>
     <a:masterClrMapping/>
   </p:clrMapOvr>
+  <mc:AlternateContent xmlns:mc="http://schemas.openxmlformats.org/markup-compatibility/2006">
+    <mc:Choice xmlns:p159="http://schemas.microsoft.com/office/powerpoint/2015/09/main" Requires="p159">
+      <p:transition xmlns:p14="http://schemas.microsoft.com/office/powerpoint/2010/main" spd="slow" p14:dur="1250">
+        <p159:morph option="byObject"/>
+      </p:transition>
+    </mc:Choice>
+    <mc:Fallback>
+      <p:transition spd="slow">
+        <p:fade/>
+      </p:transition>
+    </mc:Fallback>
+  </mc:AlternateContent>
 </p:sld>
 </file>
 
@@ -39597,7 +39813,7 @@
       </p:sp>
       <p:sp>
         <p:nvSpPr>
-          <p:cNvPr id="4" name="Shape 2"/>
+          <p:cNvPr id="4" name="!!card0"/>
           <p:cNvSpPr/>
           <p:nvPr/>
         </p:nvSpPr>
@@ -39694,7 +39910,7 @@
       </p:sp>
       <p:sp>
         <p:nvSpPr>
-          <p:cNvPr id="7" name="Shape 4"/>
+          <p:cNvPr id="7" name="!!card1"/>
           <p:cNvSpPr/>
           <p:nvPr/>
         </p:nvSpPr>
@@ -39728,7 +39944,7 @@
       </p:sp>
       <p:sp>
         <p:nvSpPr>
-          <p:cNvPr id="8" name="Shape 5"/>
+          <p:cNvPr id="8" name="!!dot0"/>
           <p:cNvSpPr/>
           <p:nvPr/>
         </p:nvSpPr>
@@ -39753,7 +39969,7 @@
       </p:sp>
       <p:pic>
         <p:nvPicPr>
-          <p:cNvPr id="9" name="Image 1" descr="preencoded.png">    </p:cNvPr>
+          <p:cNvPr id="9" name="!!ico0" descr="preencoded.png">    </p:cNvPr>
           <p:cNvPicPr>
             <a:picLocks noChangeAspect="1"/>
           </p:cNvPicPr>
@@ -39869,7 +40085,7 @@
       </p:sp>
       <p:sp>
         <p:nvSpPr>
-          <p:cNvPr id="12" name="Shape 8"/>
+          <p:cNvPr id="12" name="!!card2"/>
           <p:cNvSpPr/>
           <p:nvPr/>
         </p:nvSpPr>
@@ -39903,7 +40119,7 @@
       </p:sp>
       <p:sp>
         <p:nvSpPr>
-          <p:cNvPr id="13" name="Shape 9"/>
+          <p:cNvPr id="13" name="!!dot1"/>
           <p:cNvSpPr/>
           <p:nvPr/>
         </p:nvSpPr>
@@ -39928,7 +40144,7 @@
       </p:sp>
       <p:pic>
         <p:nvPicPr>
-          <p:cNvPr id="14" name="Image 2" descr="preencoded.png">    </p:cNvPr>
+          <p:cNvPr id="14" name="!!ico1" descr="preencoded.png">    </p:cNvPr>
           <p:cNvPicPr>
             <a:picLocks noChangeAspect="1"/>
           </p:cNvPicPr>
@@ -40044,7 +40260,7 @@
       </p:sp>
       <p:sp>
         <p:nvSpPr>
-          <p:cNvPr id="17" name="Shape 12"/>
+          <p:cNvPr id="17" name="!!card3"/>
           <p:cNvSpPr/>
           <p:nvPr/>
         </p:nvSpPr>
@@ -40078,7 +40294,7 @@
       </p:sp>
       <p:sp>
         <p:nvSpPr>
-          <p:cNvPr id="18" name="Shape 13"/>
+          <p:cNvPr id="18" name="!!dot2"/>
           <p:cNvSpPr/>
           <p:nvPr/>
         </p:nvSpPr>
@@ -40103,7 +40319,7 @@
       </p:sp>
       <p:pic>
         <p:nvPicPr>
-          <p:cNvPr id="19" name="Image 3" descr="preencoded.png">    </p:cNvPr>
+          <p:cNvPr id="19" name="!!ico2" descr="preencoded.png">    </p:cNvPr>
           <p:cNvPicPr>
             <a:picLocks noChangeAspect="1"/>
           </p:cNvPicPr>
@@ -40219,7 +40435,7 @@
       </p:sp>
       <p:sp>
         <p:nvSpPr>
-          <p:cNvPr id="22" name="Shape 16"/>
+          <p:cNvPr id="22" name="!!card4"/>
           <p:cNvSpPr/>
           <p:nvPr/>
         </p:nvSpPr>
@@ -40253,7 +40469,7 @@
       </p:sp>
       <p:sp>
         <p:nvSpPr>
-          <p:cNvPr id="23" name="Shape 17"/>
+          <p:cNvPr id="23" name="!!dot3"/>
           <p:cNvSpPr/>
           <p:nvPr/>
         </p:nvSpPr>
@@ -40278,7 +40494,7 @@
       </p:sp>
       <p:pic>
         <p:nvPicPr>
-          <p:cNvPr id="24" name="Image 4" descr="preencoded.png">    </p:cNvPr>
+          <p:cNvPr id="24" name="!!ico3" descr="preencoded.png">    </p:cNvPr>
           <p:cNvPicPr>
             <a:picLocks noChangeAspect="1"/>
           </p:cNvPicPr>
@@ -40445,6 +40661,18 @@
   <p:clrMapOvr>
     <a:masterClrMapping/>
   </p:clrMapOvr>
+  <mc:AlternateContent xmlns:mc="http://schemas.openxmlformats.org/markup-compatibility/2006">
+    <mc:Choice xmlns:p159="http://schemas.microsoft.com/office/powerpoint/2015/09/main" Requires="p159">
+      <p:transition xmlns:p14="http://schemas.microsoft.com/office/powerpoint/2010/main" spd="slow" p14:dur="1250">
+        <p159:morph option="byObject"/>
+      </p:transition>
+    </mc:Choice>
+    <mc:Fallback>
+      <p:transition spd="slow">
+        <p:fade/>
+      </p:transition>
+    </mc:Fallback>
+  </mc:AlternateContent>
 </p:sld>
 </file>
 
@@ -40549,7 +40777,7 @@
       </p:sp>
       <p:sp>
         <p:nvSpPr>
-          <p:cNvPr id="4" name="Shape 2"/>
+          <p:cNvPr id="4" name="!!card0"/>
           <p:cNvSpPr/>
           <p:nvPr/>
         </p:nvSpPr>
@@ -40622,7 +40850,7 @@
       </p:sp>
       <p:sp>
         <p:nvSpPr>
-          <p:cNvPr id="6" name="Shape 4"/>
+          <p:cNvPr id="6" name="!!dot0"/>
           <p:cNvSpPr/>
           <p:nvPr/>
         </p:nvSpPr>
@@ -40647,7 +40875,7 @@
       </p:sp>
       <p:pic>
         <p:nvPicPr>
-          <p:cNvPr id="7" name="Image 0" descr="preencoded.png">    </p:cNvPr>
+          <p:cNvPr id="7" name="!!ico0" descr="preencoded.png">    </p:cNvPr>
           <p:cNvPicPr>
             <a:picLocks noChangeAspect="1"/>
           </p:cNvPicPr>
@@ -40752,7 +40980,7 @@
       </p:sp>
       <p:sp>
         <p:nvSpPr>
-          <p:cNvPr id="10" name="Shape 7"/>
+          <p:cNvPr id="10" name="!!card1"/>
           <p:cNvSpPr/>
           <p:nvPr/>
         </p:nvSpPr>
@@ -40825,7 +41053,7 @@
       </p:sp>
       <p:sp>
         <p:nvSpPr>
-          <p:cNvPr id="12" name="Shape 9"/>
+          <p:cNvPr id="12" name="!!dot1"/>
           <p:cNvSpPr/>
           <p:nvPr/>
         </p:nvSpPr>
@@ -40850,7 +41078,7 @@
       </p:sp>
       <p:pic>
         <p:nvPicPr>
-          <p:cNvPr id="13" name="Image 1" descr="preencoded.png">    </p:cNvPr>
+          <p:cNvPr id="13" name="!!ico1" descr="preencoded.png">    </p:cNvPr>
           <p:cNvPicPr>
             <a:picLocks noChangeAspect="1"/>
           </p:cNvPicPr>
@@ -40955,7 +41183,7 @@
       </p:sp>
       <p:sp>
         <p:nvSpPr>
-          <p:cNvPr id="16" name="Shape 12"/>
+          <p:cNvPr id="16" name="!!card2"/>
           <p:cNvSpPr/>
           <p:nvPr/>
         </p:nvSpPr>
@@ -41028,7 +41256,7 @@
       </p:sp>
       <p:sp>
         <p:nvSpPr>
-          <p:cNvPr id="18" name="Shape 14"/>
+          <p:cNvPr id="18" name="!!dot2"/>
           <p:cNvSpPr/>
           <p:nvPr/>
         </p:nvSpPr>
@@ -41053,7 +41281,7 @@
       </p:sp>
       <p:pic>
         <p:nvPicPr>
-          <p:cNvPr id="19" name="Image 2" descr="preencoded.png">    </p:cNvPr>
+          <p:cNvPr id="19" name="!!ico2" descr="preencoded.png">    </p:cNvPr>
           <p:cNvPicPr>
             <a:picLocks noChangeAspect="1"/>
           </p:cNvPicPr>
@@ -41158,7 +41386,7 @@
       </p:sp>
       <p:sp>
         <p:nvSpPr>
-          <p:cNvPr id="22" name="Shape 17"/>
+          <p:cNvPr id="22" name="!!card3"/>
           <p:cNvSpPr/>
           <p:nvPr/>
         </p:nvSpPr>
@@ -41231,7 +41459,7 @@
       </p:sp>
       <p:sp>
         <p:nvSpPr>
-          <p:cNvPr id="24" name="Shape 19"/>
+          <p:cNvPr id="24" name="!!dot3"/>
           <p:cNvSpPr/>
           <p:nvPr/>
         </p:nvSpPr>
@@ -41256,7 +41484,7 @@
       </p:sp>
       <p:pic>
         <p:nvPicPr>
-          <p:cNvPr id="25" name="Image 3" descr="preencoded.png">    </p:cNvPr>
+          <p:cNvPr id="25" name="!!ico3" descr="preencoded.png">    </p:cNvPr>
           <p:cNvPicPr>
             <a:picLocks noChangeAspect="1"/>
           </p:cNvPicPr>
@@ -41361,7 +41589,7 @@
       </p:sp>
       <p:sp>
         <p:nvSpPr>
-          <p:cNvPr id="28" name="Shape 22"/>
+          <p:cNvPr id="28" name="!!card4"/>
           <p:cNvSpPr/>
           <p:nvPr/>
         </p:nvSpPr>
@@ -41434,7 +41662,7 @@
       </p:sp>
       <p:sp>
         <p:nvSpPr>
-          <p:cNvPr id="30" name="Shape 24"/>
+          <p:cNvPr id="30" name="!!dot4"/>
           <p:cNvSpPr/>
           <p:nvPr/>
         </p:nvSpPr>
@@ -41459,7 +41687,7 @@
       </p:sp>
       <p:pic>
         <p:nvPicPr>
-          <p:cNvPr id="31" name="Image 4" descr="preencoded.png">    </p:cNvPr>
+          <p:cNvPr id="31" name="!!ico4" descr="preencoded.png">    </p:cNvPr>
           <p:cNvPicPr>
             <a:picLocks noChangeAspect="1"/>
           </p:cNvPicPr>
@@ -41615,6 +41843,18 @@
   <p:clrMapOvr>
     <a:masterClrMapping/>
   </p:clrMapOvr>
+  <mc:AlternateContent xmlns:mc="http://schemas.openxmlformats.org/markup-compatibility/2006">
+    <mc:Choice xmlns:p159="http://schemas.microsoft.com/office/powerpoint/2015/09/main" Requires="p159">
+      <p:transition xmlns:p14="http://schemas.microsoft.com/office/powerpoint/2010/main" spd="slow" p14:dur="1250">
+        <p159:morph option="byObject"/>
+      </p:transition>
+    </mc:Choice>
+    <mc:Fallback>
+      <p:transition spd="slow">
+        <p:fade/>
+      </p:transition>
+    </mc:Fallback>
+  </mc:AlternateContent>
 </p:sld>
 </file>
 
@@ -41719,7 +41959,7 @@
       </p:sp>
       <p:sp>
         <p:nvSpPr>
-          <p:cNvPr id="4" name="Shape 2"/>
+          <p:cNvPr id="4" name="!!card0"/>
           <p:cNvSpPr/>
           <p:nvPr/>
         </p:nvSpPr>
@@ -41753,7 +41993,7 @@
       </p:sp>
       <p:sp>
         <p:nvSpPr>
-          <p:cNvPr id="5" name="Shape 3"/>
+          <p:cNvPr id="5" name="!!dot0"/>
           <p:cNvSpPr/>
           <p:nvPr/>
         </p:nvSpPr>
@@ -41778,7 +42018,7 @@
       </p:sp>
       <p:pic>
         <p:nvPicPr>
-          <p:cNvPr id="6" name="Image 0" descr="preencoded.png">    </p:cNvPr>
+          <p:cNvPr id="6" name="!!ico0" descr="preencoded.png">    </p:cNvPr>
           <p:cNvPicPr>
             <a:picLocks noChangeAspect="1"/>
           </p:cNvPicPr>
@@ -41883,7 +42123,7 @@
       </p:sp>
       <p:sp>
         <p:nvSpPr>
-          <p:cNvPr id="9" name="Shape 6"/>
+          <p:cNvPr id="9" name="!!card1"/>
           <p:cNvSpPr/>
           <p:nvPr/>
         </p:nvSpPr>
@@ -41917,7 +42157,7 @@
       </p:sp>
       <p:sp>
         <p:nvSpPr>
-          <p:cNvPr id="10" name="Shape 7"/>
+          <p:cNvPr id="10" name="!!dot1"/>
           <p:cNvSpPr/>
           <p:nvPr/>
         </p:nvSpPr>
@@ -41942,7 +42182,7 @@
       </p:sp>
       <p:pic>
         <p:nvPicPr>
-          <p:cNvPr id="11" name="Image 1" descr="preencoded.png">    </p:cNvPr>
+          <p:cNvPr id="11" name="!!ico1" descr="preencoded.png">    </p:cNvPr>
           <p:cNvPicPr>
             <a:picLocks noChangeAspect="1"/>
           </p:cNvPicPr>
@@ -42047,7 +42287,7 @@
       </p:sp>
       <p:sp>
         <p:nvSpPr>
-          <p:cNvPr id="14" name="Shape 10"/>
+          <p:cNvPr id="14" name="!!card2"/>
           <p:cNvSpPr/>
           <p:nvPr/>
         </p:nvSpPr>
@@ -42081,7 +42321,7 @@
       </p:sp>
       <p:sp>
         <p:nvSpPr>
-          <p:cNvPr id="15" name="Shape 11"/>
+          <p:cNvPr id="15" name="!!dot2"/>
           <p:cNvSpPr/>
           <p:nvPr/>
         </p:nvSpPr>
@@ -42106,7 +42346,7 @@
       </p:sp>
       <p:pic>
         <p:nvPicPr>
-          <p:cNvPr id="16" name="Image 2" descr="preencoded.png">    </p:cNvPr>
+          <p:cNvPr id="16" name="!!ico2" descr="preencoded.png">    </p:cNvPr>
           <p:cNvPicPr>
             <a:picLocks noChangeAspect="1"/>
           </p:cNvPicPr>
@@ -42211,7 +42451,7 @@
       </p:sp>
       <p:sp>
         <p:nvSpPr>
-          <p:cNvPr id="19" name="Shape 14"/>
+          <p:cNvPr id="19" name="!!card3"/>
           <p:cNvSpPr/>
           <p:nvPr/>
         </p:nvSpPr>
@@ -42245,7 +42485,7 @@
       </p:sp>
       <p:sp>
         <p:nvSpPr>
-          <p:cNvPr id="20" name="Shape 15"/>
+          <p:cNvPr id="20" name="!!dot3"/>
           <p:cNvSpPr/>
           <p:nvPr/>
         </p:nvSpPr>
@@ -42270,7 +42510,7 @@
       </p:sp>
       <p:pic>
         <p:nvPicPr>
-          <p:cNvPr id="21" name="Image 3" descr="preencoded.png">    </p:cNvPr>
+          <p:cNvPr id="21" name="!!ico3" descr="preencoded.png">    </p:cNvPr>
           <p:cNvPicPr>
             <a:picLocks noChangeAspect="1"/>
           </p:cNvPicPr>
@@ -42375,7 +42615,7 @@
       </p:sp>
       <p:sp>
         <p:nvSpPr>
-          <p:cNvPr id="24" name="Shape 18"/>
+          <p:cNvPr id="24" name="!!card4"/>
           <p:cNvSpPr/>
           <p:nvPr/>
         </p:nvSpPr>
@@ -42409,7 +42649,7 @@
       </p:sp>
       <p:sp>
         <p:nvSpPr>
-          <p:cNvPr id="25" name="Shape 19"/>
+          <p:cNvPr id="25" name="!!dot4"/>
           <p:cNvSpPr/>
           <p:nvPr/>
         </p:nvSpPr>
@@ -42434,7 +42674,7 @@
       </p:sp>
       <p:pic>
         <p:nvPicPr>
-          <p:cNvPr id="26" name="Image 4" descr="preencoded.png">    </p:cNvPr>
+          <p:cNvPr id="26" name="!!ico4" descr="preencoded.png">    </p:cNvPr>
           <p:cNvPicPr>
             <a:picLocks noChangeAspect="1"/>
           </p:cNvPicPr>
@@ -42539,7 +42779,7 @@
       </p:sp>
       <p:sp>
         <p:nvSpPr>
-          <p:cNvPr id="29" name="Shape 22"/>
+          <p:cNvPr id="29" name="!!card5"/>
           <p:cNvSpPr/>
           <p:nvPr/>
         </p:nvSpPr>
@@ -42573,7 +42813,7 @@
       </p:sp>
       <p:sp>
         <p:nvSpPr>
-          <p:cNvPr id="30" name="Shape 23"/>
+          <p:cNvPr id="30" name="!!dot5"/>
           <p:cNvSpPr/>
           <p:nvPr/>
         </p:nvSpPr>
@@ -42598,7 +42838,7 @@
       </p:sp>
       <p:pic>
         <p:nvPicPr>
-          <p:cNvPr id="31" name="Image 5" descr="preencoded.png">    </p:cNvPr>
+          <p:cNvPr id="31" name="!!ico5" descr="preencoded.png">    </p:cNvPr>
           <p:cNvPicPr>
             <a:picLocks noChangeAspect="1"/>
           </p:cNvPicPr>
@@ -42703,7 +42943,7 @@
       </p:sp>
       <p:sp>
         <p:nvSpPr>
-          <p:cNvPr id="34" name="Shape 26"/>
+          <p:cNvPr id="34" name="!!card6"/>
           <p:cNvSpPr/>
           <p:nvPr/>
         </p:nvSpPr>
@@ -42737,7 +42977,7 @@
       </p:sp>
       <p:sp>
         <p:nvSpPr>
-          <p:cNvPr id="35" name="Shape 27"/>
+          <p:cNvPr id="35" name="!!dot6"/>
           <p:cNvSpPr/>
           <p:nvPr/>
         </p:nvSpPr>
@@ -42762,7 +43002,7 @@
       </p:sp>
       <p:pic>
         <p:nvPicPr>
-          <p:cNvPr id="36" name="Image 6" descr="preencoded.png">    </p:cNvPr>
+          <p:cNvPr id="36" name="!!ico6" descr="preencoded.png">    </p:cNvPr>
           <p:cNvPicPr>
             <a:picLocks noChangeAspect="1"/>
           </p:cNvPicPr>
@@ -42867,7 +43107,7 @@
       </p:sp>
       <p:sp>
         <p:nvSpPr>
-          <p:cNvPr id="39" name="Shape 30"/>
+          <p:cNvPr id="39" name="!!card7"/>
           <p:cNvSpPr/>
           <p:nvPr/>
         </p:nvSpPr>
@@ -43054,6 +43294,18 @@
   <p:clrMapOvr>
     <a:masterClrMapping/>
   </p:clrMapOvr>
+  <mc:AlternateContent xmlns:mc="http://schemas.openxmlformats.org/markup-compatibility/2006">
+    <mc:Choice xmlns:p159="http://schemas.microsoft.com/office/powerpoint/2015/09/main" Requires="p159">
+      <p:transition xmlns:p14="http://schemas.microsoft.com/office/powerpoint/2010/main" spd="slow" p14:dur="1250">
+        <p159:morph option="byObject"/>
+      </p:transition>
+    </mc:Choice>
+    <mc:Fallback>
+      <p:transition spd="slow">
+        <p:fade/>
+      </p:transition>
+    </mc:Fallback>
+  </mc:AlternateContent>
 </p:sld>
 </file>
 
@@ -43158,7 +43410,7 @@
       </p:sp>
       <p:sp>
         <p:nvSpPr>
-          <p:cNvPr id="4" name="Shape 2"/>
+          <p:cNvPr id="4" name="!!card0"/>
           <p:cNvSpPr/>
           <p:nvPr/>
         </p:nvSpPr>
@@ -43192,7 +43444,7 @@
       </p:sp>
       <p:sp>
         <p:nvSpPr>
-          <p:cNvPr id="5" name="Shape 3"/>
+          <p:cNvPr id="5" name="!!dot0"/>
           <p:cNvSpPr/>
           <p:nvPr/>
         </p:nvSpPr>
@@ -43217,7 +43469,7 @@
       </p:sp>
       <p:pic>
         <p:nvPicPr>
-          <p:cNvPr id="6" name="Image 0" descr="preencoded.png">    </p:cNvPr>
+          <p:cNvPr id="6" name="!!ico0" descr="preencoded.png">    </p:cNvPr>
           <p:cNvPicPr>
             <a:picLocks noChangeAspect="1"/>
           </p:cNvPicPr>
@@ -43322,7 +43574,7 @@
       </p:sp>
       <p:sp>
         <p:nvSpPr>
-          <p:cNvPr id="9" name="Shape 6"/>
+          <p:cNvPr id="9" name="!!card1"/>
           <p:cNvSpPr/>
           <p:nvPr/>
         </p:nvSpPr>
@@ -43356,7 +43608,7 @@
       </p:sp>
       <p:sp>
         <p:nvSpPr>
-          <p:cNvPr id="10" name="Shape 7"/>
+          <p:cNvPr id="10" name="!!dot1"/>
           <p:cNvSpPr/>
           <p:nvPr/>
         </p:nvSpPr>
@@ -43381,7 +43633,7 @@
       </p:sp>
       <p:pic>
         <p:nvPicPr>
-          <p:cNvPr id="11" name="Image 1" descr="preencoded.png">    </p:cNvPr>
+          <p:cNvPr id="11" name="!!ico1" descr="preencoded.png">    </p:cNvPr>
           <p:cNvPicPr>
             <a:picLocks noChangeAspect="1"/>
           </p:cNvPicPr>
@@ -43486,7 +43738,7 @@
       </p:sp>
       <p:sp>
         <p:nvSpPr>
-          <p:cNvPr id="14" name="Shape 10"/>
+          <p:cNvPr id="14" name="!!card2"/>
           <p:cNvSpPr/>
           <p:nvPr/>
         </p:nvSpPr>
@@ -43520,7 +43772,7 @@
       </p:sp>
       <p:sp>
         <p:nvSpPr>
-          <p:cNvPr id="15" name="Shape 11"/>
+          <p:cNvPr id="15" name="!!dot2"/>
           <p:cNvSpPr/>
           <p:nvPr/>
         </p:nvSpPr>
@@ -43545,7 +43797,7 @@
       </p:sp>
       <p:pic>
         <p:nvPicPr>
-          <p:cNvPr id="16" name="Image 2" descr="preencoded.png">    </p:cNvPr>
+          <p:cNvPr id="16" name="!!ico2" descr="preencoded.png">    </p:cNvPr>
           <p:cNvPicPr>
             <a:picLocks noChangeAspect="1"/>
           </p:cNvPicPr>
@@ -43650,7 +43902,7 @@
       </p:sp>
       <p:sp>
         <p:nvSpPr>
-          <p:cNvPr id="19" name="Shape 14"/>
+          <p:cNvPr id="19" name="!!card3"/>
           <p:cNvSpPr/>
           <p:nvPr/>
         </p:nvSpPr>
@@ -43684,7 +43936,7 @@
       </p:sp>
       <p:sp>
         <p:nvSpPr>
-          <p:cNvPr id="20" name="Shape 15"/>
+          <p:cNvPr id="20" name="!!dot3"/>
           <p:cNvSpPr/>
           <p:nvPr/>
         </p:nvSpPr>
@@ -43709,7 +43961,7 @@
       </p:sp>
       <p:pic>
         <p:nvPicPr>
-          <p:cNvPr id="21" name="Image 3" descr="preencoded.png">    </p:cNvPr>
+          <p:cNvPr id="21" name="!!ico3" descr="preencoded.png">    </p:cNvPr>
           <p:cNvPicPr>
             <a:picLocks noChangeAspect="1"/>
           </p:cNvPicPr>
@@ -43814,7 +44066,7 @@
       </p:sp>
       <p:sp>
         <p:nvSpPr>
-          <p:cNvPr id="24" name="Shape 18"/>
+          <p:cNvPr id="24" name="!!card4"/>
           <p:cNvSpPr/>
           <p:nvPr/>
         </p:nvSpPr>
@@ -43848,7 +44100,7 @@
       </p:sp>
       <p:sp>
         <p:nvSpPr>
-          <p:cNvPr id="25" name="Shape 19"/>
+          <p:cNvPr id="25" name="!!dot4"/>
           <p:cNvSpPr/>
           <p:nvPr/>
         </p:nvSpPr>
@@ -43873,7 +44125,7 @@
       </p:sp>
       <p:pic>
         <p:nvPicPr>
-          <p:cNvPr id="26" name="Image 4" descr="preencoded.png">    </p:cNvPr>
+          <p:cNvPr id="26" name="!!ico4" descr="preencoded.png">    </p:cNvPr>
           <p:cNvPicPr>
             <a:picLocks noChangeAspect="1"/>
           </p:cNvPicPr>
@@ -43978,7 +44230,7 @@
       </p:sp>
       <p:sp>
         <p:nvSpPr>
-          <p:cNvPr id="29" name="Shape 22"/>
+          <p:cNvPr id="29" name="!!card5"/>
           <p:cNvSpPr/>
           <p:nvPr/>
         </p:nvSpPr>
@@ -44012,7 +44264,7 @@
       </p:sp>
       <p:sp>
         <p:nvSpPr>
-          <p:cNvPr id="30" name="Shape 23"/>
+          <p:cNvPr id="30" name="!!dot5"/>
           <p:cNvSpPr/>
           <p:nvPr/>
         </p:nvSpPr>
@@ -44037,7 +44289,7 @@
       </p:sp>
       <p:pic>
         <p:nvPicPr>
-          <p:cNvPr id="31" name="Image 5" descr="preencoded.png">    </p:cNvPr>
+          <p:cNvPr id="31" name="!!ico5" descr="preencoded.png">    </p:cNvPr>
           <p:cNvPicPr>
             <a:picLocks noChangeAspect="1"/>
           </p:cNvPicPr>
@@ -44142,7 +44394,7 @@
       </p:sp>
       <p:sp>
         <p:nvSpPr>
-          <p:cNvPr id="34" name="Shape 26"/>
+          <p:cNvPr id="34" name="!!card6"/>
           <p:cNvSpPr/>
           <p:nvPr/>
         </p:nvSpPr>
@@ -44176,7 +44428,7 @@
       </p:sp>
       <p:sp>
         <p:nvSpPr>
-          <p:cNvPr id="35" name="Shape 27"/>
+          <p:cNvPr id="35" name="!!dot6"/>
           <p:cNvSpPr/>
           <p:nvPr/>
         </p:nvSpPr>
@@ -44201,7 +44453,7 @@
       </p:sp>
       <p:pic>
         <p:nvPicPr>
-          <p:cNvPr id="36" name="Image 6" descr="preencoded.png">    </p:cNvPr>
+          <p:cNvPr id="36" name="!!ico6" descr="preencoded.png">    </p:cNvPr>
           <p:cNvPicPr>
             <a:picLocks noChangeAspect="1"/>
           </p:cNvPicPr>
@@ -44306,7 +44558,7 @@
       </p:sp>
       <p:sp>
         <p:nvSpPr>
-          <p:cNvPr id="39" name="Shape 30"/>
+          <p:cNvPr id="39" name="!!card7"/>
           <p:cNvSpPr/>
           <p:nvPr/>
         </p:nvSpPr>
@@ -44493,6 +44745,18 @@
   <p:clrMapOvr>
     <a:masterClrMapping/>
   </p:clrMapOvr>
+  <mc:AlternateContent xmlns:mc="http://schemas.openxmlformats.org/markup-compatibility/2006">
+    <mc:Choice xmlns:p159="http://schemas.microsoft.com/office/powerpoint/2015/09/main" Requires="p159">
+      <p:transition xmlns:p14="http://schemas.microsoft.com/office/powerpoint/2010/main" spd="slow" p14:dur="1250">
+        <p159:morph option="byObject"/>
+      </p:transition>
+    </mc:Choice>
+    <mc:Fallback>
+      <p:transition spd="slow">
+        <p:fade/>
+      </p:transition>
+    </mc:Fallback>
+  </mc:AlternateContent>
 </p:sld>
 </file>
 
@@ -44597,7 +44861,7 @@
       </p:sp>
       <p:sp>
         <p:nvSpPr>
-          <p:cNvPr id="4" name="Shape 2"/>
+          <p:cNvPr id="4" name="!!card0"/>
           <p:cNvSpPr/>
           <p:nvPr/>
         </p:nvSpPr>
@@ -44851,7 +45115,7 @@
       </p:sp>
       <p:sp>
         <p:nvSpPr>
-          <p:cNvPr id="9" name="Shape 7"/>
+          <p:cNvPr id="9" name="!!card1"/>
           <p:cNvSpPr/>
           <p:nvPr/>
         </p:nvSpPr>
@@ -45105,7 +45369,7 @@
       </p:sp>
       <p:sp>
         <p:nvSpPr>
-          <p:cNvPr id="14" name="Shape 12"/>
+          <p:cNvPr id="14" name="!!card2"/>
           <p:cNvSpPr/>
           <p:nvPr/>
         </p:nvSpPr>
@@ -45380,7 +45644,7 @@
       </p:sp>
       <p:sp>
         <p:nvSpPr>
-          <p:cNvPr id="19" name="Shape 17"/>
+          <p:cNvPr id="19" name="!!card3"/>
           <p:cNvSpPr/>
           <p:nvPr/>
         </p:nvSpPr>
@@ -45655,7 +45919,7 @@
       </p:sp>
       <p:sp>
         <p:nvSpPr>
-          <p:cNvPr id="24" name="Shape 22"/>
+          <p:cNvPr id="24" name="!!card4"/>
           <p:cNvSpPr/>
           <p:nvPr/>
         </p:nvSpPr>
@@ -45810,6 +46074,18 @@
   <p:clrMapOvr>
     <a:masterClrMapping/>
   </p:clrMapOvr>
+  <mc:AlternateContent xmlns:mc="http://schemas.openxmlformats.org/markup-compatibility/2006">
+    <mc:Choice xmlns:p159="http://schemas.microsoft.com/office/powerpoint/2015/09/main" Requires="p159">
+      <p:transition xmlns:p14="http://schemas.microsoft.com/office/powerpoint/2010/main" spd="slow" p14:dur="1250">
+        <p159:morph option="byObject"/>
+      </p:transition>
+    </mc:Choice>
+    <mc:Fallback>
+      <p:transition spd="slow">
+        <p:fade/>
+      </p:transition>
+    </mc:Fallback>
+  </mc:AlternateContent>
 </p:sld>
 </file>
 

</xml_diff>